<commit_message>
Update draft slides with the finished 3-trial qualitative review
Slides 11-15 now cite the 3-trial review (findings log section 23, draft
PR #8) instead of the preliminary notes. Slide 15 shows attempted writes
per model and the projected "no write attempted" check (M1.27). The
weak-points slide names the LLM labellers and the task 48 twin problem.

Co-Authored-By: Claude Opus 5.5 (1M context) <noreply@anthropic.com>
Claude-Session: https://claude.ai/code/session_01MtfJPedLYuXacbp8WXfd3s
</commit_message>
<xml_diff>
--- a/docs/drafts/2026-10-10-presentation-no-op-validity.pptx
+++ b/docs/drafts/2026-10-10-presentation-no-op-validity.pptx
@@ -660,7 +660,7 @@
           <a:lstStyle/>
           <a:p>
             <a:r>
-              <a:t>Rubric: two questions per removal. Q1, was the original no-action pass reasoned? Q2, why did the gate fail: the intended catch, an unrelated agent error, the user script or simulator, or a lost tool call. "Right, wrong cause" means the original was unreasoned but the gate fired for another reason. These numbers come from a review that is still being checked; treat as preliminary.</a:t>
+              <a:t>Rubric: two questions per removal. Q1, was the original no-action pass reasoned? Q2, why did the gate fail: the intended catch, an unrelated agent error, the user script or simulator, or a lost tool call. "Right, wrong cause" means the original was unreasoned but the gate fired for another reason. The labels come from LLM reviewers, with no blind second labeller yet.</a:t>
             </a:r>
           </a:p>
         </p:txBody>
@@ -940,7 +940,7 @@
           <a:lstStyle/>
           <a:p>
             <a:r>
-              <a:t>Unreasoned passes that every gate keeps, over 3 seeds: haiku 12, maverick 15, nano 5, luna 0 (no-op-review/highlights.md §4). This is close to the formalization's "no forbidden writes" check, which we set aside on 2026-10-03. Bringing it back needs a decisions-log entry. The attempts are in the trajectory already, so it is a re-score, not a re-run.</a:t>
+              <a:t>An attempted write is a real call that failed or changed nothing, or a write typed as text and lost. Most are maverick's. The projection is of the headline score (reads plus all twins) and is not yet computed by the scoreboard. The null agent stays at 3. This revives something close to the formalization's "no forbidden writes" check, set aside on 2026-10-03, so it needs a decisions-log entry.</a:t>
             </a:r>
           </a:p>
         </p:txBody>

</xml_diff>

<commit_message>
Revise draft slides: traces, per-gate slides, lenient twins
Add a slide with two gpt-6-luna traces that reach "no change" by
accident, and one slide each on where and how the read gate, DB twins
and policy twins apply. The results table now shows each gate's
removal alone, and the charts have axes. All twin scores use the
lenient rule, and slide titles name the topic.

Implements 2026-10-15 decision: the presentation uses the lenient twin
rule only.

Co-Authored-By: Claude Opus 5.5 (1M context) <noreply@anthropic.com>
Claude-Session: https://claude.ai/code/session_01MtfJPedLYuXacbp8WXfd3s
</commit_message>
<xml_diff>
--- a/docs/drafts/2026-10-10-presentation-no-op-validity.pptx
+++ b/docs/drafts/2026-10-10-presentation-no-op-validity.pptx
@@ -24,6 +24,10 @@
     <p:sldId id="272" r:id="rId24"/>
     <p:sldId id="273" r:id="rId25"/>
     <p:sldId id="274" r:id="rId26"/>
+    <p:sldId id="275" r:id="rId27"/>
+    <p:sldId id="276" r:id="rId28"/>
+    <p:sldId id="277" r:id="rId29"/>
+    <p:sldId id="278" r:id="rId30"/>
   </p:sldIdLst>
   <p:sldSz cx="12192000" cy="6858000" type="screen4x3"/>
   <p:notesSz cx="6858000" cy="9144000"/>
@@ -590,7 +594,7 @@
           <a:lstStyle/>
           <a:p>
             <a:r>
-              <a:t>On the original score maverick (22.7) is almost tied with haiku (24.3). After both gates it is 6 points below. The ranking among these four does not flip, but the gaps change a lot.</a:t>
+              <a:t>The policy-as-code oracle is what lets us search for the flip mechanically instead of guessing. Validation runs the real tau2 evaluator on scripted trajectories, and checks that the patch changes only the named records. Task 4 was dropped after a live run showed the user's goal could not be reached. Lenient scoring: a twin counts as passed when the right write happened, even if the episode failed for another reason.</a:t>
             </a:r>
           </a:p>
         </p:txBody>
@@ -660,7 +664,7 @@
           <a:lstStyle/>
           <a:p>
             <a:r>
-              <a:t>Rubric: two questions per removal. Q1, was the original no-action pass reasoned? Q2, why did the gate fail: the intended catch, an unrelated agent error, the user script or simulator, or a lost tool call. "Right, wrong cause" means the original was unreasoned but the gate fired for another reason. The labels come from LLM reviewers, with no blind second labeller yet.</a:t>
+              <a:t>Changing a policy sentence is the only way to make the right answer a write when the deciding fact is a rule, not data. The scripts for tasks 2, 5 and 27 have known faults (see the qualitative slides), so this gate is the weakest of the three. Lenient scoring applies here too.</a:t>
             </a:r>
           </a:p>
         </p:txBody>
@@ -730,7 +734,7 @@
           <a:lstStyle/>
           <a:p>
             <a:r>
-              <a:t>Task 34: "delay by one day ... back by one day as well" means May 23. The agents told the customer May 21 and the customer agreed. haiku also charged $100 for bags that are free for a gold member in business. maverick types tool calls into prose; Prime drops them, so a refusal can hide a forbidden write that never ran.</a:t>
+              <a:t>Read across a row: original score, what each gate takes away alone, and the score with all three gates on. luna loses nothing to the DB pairs; its few DB-pair failures are tasks it had already failed. The policy pairs take the most from every model, but the policy twin is the least reliable gate (qualitative section). Per-trial ranges after all gates: luna 33–37, haiku 20–21, maverick 12–16, nano 13–15; maverick and nano overlap.</a:t>
             </a:r>
           </a:p>
         </p:txBody>
@@ -800,7 +804,7 @@
           <a:lstStyle/>
           <a:p>
             <a:r>
-              <a:t>This is a rule error that no read check can see: the read was made. Only the twin shows that the cabin fact does not drive haiku's decision. If we count these as true positives, the DB twin scores 6 right / 4 wrong cause / 7 false positive overall, and haiku's DB twin is 4/0/0. Decide which reading we present before the talk.</a:t>
+              <a:t>How to read it: each bar is one model. The whole bar is the share of that model's original score the three gates remove. The blue part is the read gate; the dark orange part is what the DB twins remove from the passes left after the read gate; the light orange part is what the policy twins remove after that. Numbers in the bars are percent of the original score. For example, maverick's original score is 22.7 tasks; the gates remove 8.3 of them, 36.8%. The null agent is not shown: the gates remove 20 of its 23 passes (87%).</a:t>
             </a:r>
           </a:p>
         </p:txBody>
@@ -870,7 +874,7 @@
           <a:lstStyle/>
           <a:p>
             <a:r>
-              <a:t>Caveat on task 38: in seeds 301 and 302 the twin's opener matches the original, so it tests only "transfer on turn 1". Two of the removals are wrong-mechanism, from a passenger-count dispute. Also: no original task ever expects send_certificate, so an "always pay" bot looks perfect on the originals and passes the task 2 twin.</a:t>
+              <a:t>The ranking among the four models does not flip, but the gaps change. On the original score maverick (22.7) is almost tied with haiku (24.3); after the gates it is 6 points below. Per-trial ranges after the gates: maverick 12–16 and nano 13–15 overlap, so their order is not reliable. The null agent falls from 23 to 3.</a:t>
             </a:r>
           </a:p>
         </p:txBody>
@@ -940,7 +944,7 @@
           <a:lstStyle/>
           <a:p>
             <a:r>
-              <a:t>An attempted write is a real call that failed or changed nothing, or a write typed as text and lost. Most are maverick's. The projection is of the headline score (reads plus all twins) and is not yet computed by the scoreboard. The null agent stays at 3. This revives something close to the formalization's "no forbidden writes" check, set aside on 2026-10-03, so it needs a decisions-log entry.</a:t>
+              <a:t>Rubric: two questions per removal. Q1, was the original no-action pass reasoned? Q2, why did the gate fail: the intended catch, an unrelated agent error, the user script or simulator, or a lost tool call. "Right, wrong cause" means the original was unreasoned but the gate fired for another reason. The labels come from LLM reviewers, with no blind second labeller yet.</a:t>
             </a:r>
           </a:p>
         </p:txBody>
@@ -1010,7 +1014,7 @@
           <a:lstStyle/>
           <a:p>
             <a:r>
-              <a:t>Step 1 is fully automatic and tells you whether steps 2 to 4 are needed at all. The airline numbers on the right are the checks this talk evaluated, packaged in the doctor. Minimum a benchmark must expose: a way to run an empty agent and a state-based grader. Twins need a settable initial state and the ability to score a hand-made trajectory. Policy flips need the policy as plain text in the agent's prompt. Every tau2 tool already carries a READ or WRITE label, so the doctor uses those instead of hand-written sets.</a:t>
+              <a:t>Task 34: "delay by one day ... back by one day as well" means May 23. The agents told the customer May 21 and the customer agreed. haiku also charged $100 for bags that are free for a gold member in business. maverick types tool calls into prose; Prime drops them, so a refusal can hide a forbidden write that never ran.</a:t>
             </a:r>
           </a:p>
         </p:txBody>
@@ -1080,7 +1084,7 @@
           <a:lstStyle/>
           <a:p>
             <a:r>
-              <a:t>In the screenshot, the top twin (reservation made within 24 hours) passes validation. The bottom one was edited by hand to a bad patch, and the grader's validation error shows right away. Every review records who approved what, and when.</a:t>
+              <a:t>This is a rule error that no read check can see: the read was made. Only the twin shows that the cabin fact does not drive haiku's decision. If we count these as true positives, the DB twin scores 6 right / 4 wrong cause / 7 false positive overall, and haiku's DB twin is 4/0/0. Decide which reading we present before the talk.</a:t>
             </a:r>
           </a:p>
         </p:txBody>
@@ -1150,7 +1154,7 @@
           <a:lstStyle/>
           <a:p>
             <a:r>
-              <a:t>Say these plainly. The reads gate result is solid. The DB twin result is solid on competent models, with known false positives from lost tool calls. The policy twin needs fixed scripts before any of its removals count as evidence.</a:t>
+              <a:t>Caveat on task 38: in seeds 301 and 302 the twin's opener matches the original, so it tests only "transfer on turn 1". Two of the removals are wrong-mechanism, from a passenger-count dispute. Also: no original task ever expects send_certificate, so an "always pay" bot looks perfect on the originals and passes the task 2 twin.</a:t>
             </a:r>
           </a:p>
         </p:txBody>
@@ -1220,7 +1224,7 @@
           <a:lstStyle/>
           <a:p>
             <a:r>
-              <a:t>Null agent 23 of 50 originally, 7 under the read gate, 3 under reads plus all twins. luna goes 39.0 to 35.7. Thank you; questions.</a:t>
+              <a:t>An attempted write is a real call that failed or changed nothing, or a write typed as text and lost. Most are maverick's. The projection is of the headline score (reads plus all twins) and is not yet computed by the scoreboard. The null agent stays at 3. This revives something close to the formalization's "no forbidden writes" check, set aside on 2026-10-03, so it needs a decisions-log entry.</a:t>
             </a:r>
           </a:p>
         </p:txBody>
@@ -1315,6 +1319,286 @@
 </p:notes>
 </file>
 
+<file path=ppt/notesSlides/notesSlide20.xml><?xml version="1.0" encoding="utf-8"?>
+<p:notes xmlns:a="http://schemas.openxmlformats.org/drawingml/2006/main" xmlns:p="http://schemas.openxmlformats.org/presentationml/2006/main" xmlns:r="http://schemas.openxmlformats.org/officeDocument/2006/relationships">
+  <p:cSld>
+    <p:spTree>
+      <p:nvGrpSpPr>
+        <p:cNvPr id="1" name=""/>
+        <p:cNvGrpSpPr/>
+        <p:nvPr/>
+      </p:nvGrpSpPr>
+      <p:grpSpPr>
+        <a:xfrm>
+          <a:off x="0" y="0"/>
+          <a:ext cx="0" cy="0"/>
+          <a:chOff x="0" y="0"/>
+          <a:chExt cx="0" cy="0"/>
+        </a:xfrm>
+      </p:grpSpPr>
+      <p:sp>
+        <p:nvSpPr>
+          <p:cNvPr id="2" name="Slide Image Placeholder 1"/>
+          <p:cNvSpPr>
+            <a:spLocks noGrp="1"/>
+          </p:cNvSpPr>
+          <p:nvPr>
+            <p:ph type="sldImg" idx="2"/>
+          </p:nvPr>
+        </p:nvSpPr>
+        <p:spPr/>
+      </p:sp>
+      <p:sp>
+        <p:nvSpPr>
+          <p:cNvPr id="3" name="Notes Placeholder 2"/>
+          <p:cNvSpPr>
+            <a:spLocks noGrp="1"/>
+          </p:cNvSpPr>
+          <p:nvPr>
+            <p:ph type="body" idx="3" sz="quarter"/>
+          </p:nvPr>
+        </p:nvSpPr>
+        <p:spPr/>
+        <p:txBody>
+          <a:bodyPr/>
+          <a:lstStyle/>
+          <a:p>
+            <a:r>
+              <a:t>Step 1 is fully automatic and tells you whether steps 2 to 4 are needed at all. The airline numbers on the right are the checks this talk evaluated, packaged in the doctor. Minimum a benchmark must expose: a way to run an empty agent and a state-based grader. Twins need a settable initial state and the ability to score a hand-made trajectory. Policy flips need the policy as plain text in the agent's prompt. Every tau2 tool already carries a READ or WRITE label, so the doctor uses those instead of hand-written sets.</a:t>
+            </a:r>
+          </a:p>
+        </p:txBody>
+      </p:sp>
+      <p:sp>
+        <p:nvSpPr>
+          <p:cNvPr id="4" name="Slide Number Placeholder 3"/>
+          <p:cNvSpPr>
+            <a:spLocks noGrp="1"/>
+          </p:cNvSpPr>
+          <p:nvPr>
+            <p:ph type="sldNum" idx="5" sz="quarter"/>
+          </p:nvPr>
+        </p:nvSpPr>
+        <p:spPr/>
+      </p:sp>
+    </p:spTree>
+  </p:cSld>
+  <p:clrMapOvr>
+    <a:masterClrMapping/>
+  </p:clrMapOvr>
+</p:notes>
+</file>
+
+<file path=ppt/notesSlides/notesSlide21.xml><?xml version="1.0" encoding="utf-8"?>
+<p:notes xmlns:a="http://schemas.openxmlformats.org/drawingml/2006/main" xmlns:p="http://schemas.openxmlformats.org/presentationml/2006/main" xmlns:r="http://schemas.openxmlformats.org/officeDocument/2006/relationships">
+  <p:cSld>
+    <p:spTree>
+      <p:nvGrpSpPr>
+        <p:cNvPr id="1" name=""/>
+        <p:cNvGrpSpPr/>
+        <p:nvPr/>
+      </p:nvGrpSpPr>
+      <p:grpSpPr>
+        <a:xfrm>
+          <a:off x="0" y="0"/>
+          <a:ext cx="0" cy="0"/>
+          <a:chOff x="0" y="0"/>
+          <a:chExt cx="0" cy="0"/>
+        </a:xfrm>
+      </p:grpSpPr>
+      <p:sp>
+        <p:nvSpPr>
+          <p:cNvPr id="2" name="Slide Image Placeholder 1"/>
+          <p:cNvSpPr>
+            <a:spLocks noGrp="1"/>
+          </p:cNvSpPr>
+          <p:nvPr>
+            <p:ph type="sldImg" idx="2"/>
+          </p:nvPr>
+        </p:nvSpPr>
+        <p:spPr/>
+      </p:sp>
+      <p:sp>
+        <p:nvSpPr>
+          <p:cNvPr id="3" name="Notes Placeholder 2"/>
+          <p:cNvSpPr>
+            <a:spLocks noGrp="1"/>
+          </p:cNvSpPr>
+          <p:nvPr>
+            <p:ph type="body" idx="3" sz="quarter"/>
+          </p:nvPr>
+        </p:nvSpPr>
+        <p:spPr/>
+        <p:txBody>
+          <a:bodyPr/>
+          <a:lstStyle/>
+          <a:p>
+            <a:r>
+              <a:t>In the screenshot, the top twin (reservation made within 24 hours) passes validation. The bottom one was edited by hand to a bad patch, and the grader's validation error shows right away. Every review records who approved what, and when.</a:t>
+            </a:r>
+          </a:p>
+        </p:txBody>
+      </p:sp>
+      <p:sp>
+        <p:nvSpPr>
+          <p:cNvPr id="4" name="Slide Number Placeholder 3"/>
+          <p:cNvSpPr>
+            <a:spLocks noGrp="1"/>
+          </p:cNvSpPr>
+          <p:nvPr>
+            <p:ph type="sldNum" idx="5" sz="quarter"/>
+          </p:nvPr>
+        </p:nvSpPr>
+        <p:spPr/>
+      </p:sp>
+    </p:spTree>
+  </p:cSld>
+  <p:clrMapOvr>
+    <a:masterClrMapping/>
+  </p:clrMapOvr>
+</p:notes>
+</file>
+
+<file path=ppt/notesSlides/notesSlide22.xml><?xml version="1.0" encoding="utf-8"?>
+<p:notes xmlns:a="http://schemas.openxmlformats.org/drawingml/2006/main" xmlns:p="http://schemas.openxmlformats.org/presentationml/2006/main" xmlns:r="http://schemas.openxmlformats.org/officeDocument/2006/relationships">
+  <p:cSld>
+    <p:spTree>
+      <p:nvGrpSpPr>
+        <p:cNvPr id="1" name=""/>
+        <p:cNvGrpSpPr/>
+        <p:nvPr/>
+      </p:nvGrpSpPr>
+      <p:grpSpPr>
+        <a:xfrm>
+          <a:off x="0" y="0"/>
+          <a:ext cx="0" cy="0"/>
+          <a:chOff x="0" y="0"/>
+          <a:chExt cx="0" cy="0"/>
+        </a:xfrm>
+      </p:grpSpPr>
+      <p:sp>
+        <p:nvSpPr>
+          <p:cNvPr id="2" name="Slide Image Placeholder 1"/>
+          <p:cNvSpPr>
+            <a:spLocks noGrp="1"/>
+          </p:cNvSpPr>
+          <p:nvPr>
+            <p:ph type="sldImg" idx="2"/>
+          </p:nvPr>
+        </p:nvSpPr>
+        <p:spPr/>
+      </p:sp>
+      <p:sp>
+        <p:nvSpPr>
+          <p:cNvPr id="3" name="Notes Placeholder 2"/>
+          <p:cNvSpPr>
+            <a:spLocks noGrp="1"/>
+          </p:cNvSpPr>
+          <p:nvPr>
+            <p:ph type="body" idx="3" sz="quarter"/>
+          </p:nvPr>
+        </p:nvSpPr>
+        <p:spPr/>
+        <p:txBody>
+          <a:bodyPr/>
+          <a:lstStyle/>
+          <a:p>
+            <a:r>
+              <a:t>Say these plainly. The reads gate result is solid. The DB twin result is solid on competent models, with known false positives from lost tool calls. The policy twin needs fixed scripts before any of its removals count as evidence.</a:t>
+            </a:r>
+          </a:p>
+        </p:txBody>
+      </p:sp>
+      <p:sp>
+        <p:nvSpPr>
+          <p:cNvPr id="4" name="Slide Number Placeholder 3"/>
+          <p:cNvSpPr>
+            <a:spLocks noGrp="1"/>
+          </p:cNvSpPr>
+          <p:nvPr>
+            <p:ph type="sldNum" idx="5" sz="quarter"/>
+          </p:nvPr>
+        </p:nvSpPr>
+        <p:spPr/>
+      </p:sp>
+    </p:spTree>
+  </p:cSld>
+  <p:clrMapOvr>
+    <a:masterClrMapping/>
+  </p:clrMapOvr>
+</p:notes>
+</file>
+
+<file path=ppt/notesSlides/notesSlide23.xml><?xml version="1.0" encoding="utf-8"?>
+<p:notes xmlns:a="http://schemas.openxmlformats.org/drawingml/2006/main" xmlns:p="http://schemas.openxmlformats.org/presentationml/2006/main" xmlns:r="http://schemas.openxmlformats.org/officeDocument/2006/relationships">
+  <p:cSld>
+    <p:spTree>
+      <p:nvGrpSpPr>
+        <p:cNvPr id="1" name=""/>
+        <p:cNvGrpSpPr/>
+        <p:nvPr/>
+      </p:nvGrpSpPr>
+      <p:grpSpPr>
+        <a:xfrm>
+          <a:off x="0" y="0"/>
+          <a:ext cx="0" cy="0"/>
+          <a:chOff x="0" y="0"/>
+          <a:chExt cx="0" cy="0"/>
+        </a:xfrm>
+      </p:grpSpPr>
+      <p:sp>
+        <p:nvSpPr>
+          <p:cNvPr id="2" name="Slide Image Placeholder 1"/>
+          <p:cNvSpPr>
+            <a:spLocks noGrp="1"/>
+          </p:cNvSpPr>
+          <p:nvPr>
+            <p:ph type="sldImg" idx="2"/>
+          </p:nvPr>
+        </p:nvSpPr>
+        <p:spPr/>
+      </p:sp>
+      <p:sp>
+        <p:nvSpPr>
+          <p:cNvPr id="3" name="Notes Placeholder 2"/>
+          <p:cNvSpPr>
+            <a:spLocks noGrp="1"/>
+          </p:cNvSpPr>
+          <p:nvPr>
+            <p:ph type="body" idx="3" sz="quarter"/>
+          </p:nvPr>
+        </p:nvSpPr>
+        <p:spPr/>
+        <p:txBody>
+          <a:bodyPr/>
+          <a:lstStyle/>
+          <a:p>
+            <a:r>
+              <a:t>Null agent 23 of 50 originally, 7 under the read gate, 3 under reads plus all twins. luna goes 39.0 to 35.7. Thank you; questions.</a:t>
+            </a:r>
+          </a:p>
+        </p:txBody>
+      </p:sp>
+      <p:sp>
+        <p:nvSpPr>
+          <p:cNvPr id="4" name="Slide Number Placeholder 3"/>
+          <p:cNvSpPr>
+            <a:spLocks noGrp="1"/>
+          </p:cNvSpPr>
+          <p:nvPr>
+            <p:ph type="sldNum" idx="5" sz="quarter"/>
+          </p:nvPr>
+        </p:nvSpPr>
+        <p:spPr/>
+      </p:sp>
+    </p:spTree>
+  </p:cSld>
+  <p:clrMapOvr>
+    <a:masterClrMapping/>
+  </p:clrMapOvr>
+</p:notes>
+</file>
+
 <file path=ppt/notesSlides/notesSlide3.xml><?xml version="1.0" encoding="utf-8"?>
 <p:notes xmlns:a="http://schemas.openxmlformats.org/drawingml/2006/main" xmlns:p="http://schemas.openxmlformats.org/presentationml/2006/main" xmlns:r="http://schemas.openxmlformats.org/officeDocument/2006/relationships">
   <p:cSld>
@@ -1500,7 +1784,7 @@
           <a:lstStyle/>
           <a:p>
             <a:r>
-              <a:t>Decision of 2026-10-03, which replaced the earlier three-check rubric. Reads alone are not enough: an agent that reads everything and then refuses everything passes them. That agent is the reason the twins exist.</a:t>
+              <a:t>Both traces end with no change to the database, so tau2 gives full credit. In task 38 the agent transfers on its first move. In task 34 the agent prices May 21, but "back by one day" from May 22 means May 23. It quotes $36 and the customer agrees; only a scripted fee dispute ends the episode before a wrong rebooking. Later slides: the read gate removes task 34 (the May 23 search never happened), and the policy twin removes task 38.</a:t>
             </a:r>
           </a:p>
         </p:txBody>
@@ -1570,7 +1854,7 @@
           <a:lstStyle/>
           <a:p>
             <a:r>
-              <a:t>The gate takes the null agent from 46% to 14% and removes only 0.6 to 2.4 points from the four models, which nearly always read before they refuse. maverick loses the most, mostly from reads typed as text and lost. So reads alone do not separate models; they are necessary, not sufficient. That motivates the twins.</a:t>
+              <a:t>Decision of 2026-10-03, which replaced the earlier three-check rubric. Reads alone are not enough: an agent that reads everything and then refuses everything passes them. That agent is the reason the twins exist.</a:t>
             </a:r>
           </a:p>
         </p:txBody>
@@ -1640,7 +1924,7 @@
           <a:lstStyle/>
           <a:p>
             <a:r>
-              <a:t>A no-action pass keeps its credit only if the paired twin also passes. Strict rule: any twin failure removes the credit. Lenient rule: the twin counts if the agent made the right write despite other errors. Every twin is checked statically: the null agent scores 1/0 on original/twin, a comply agent 0/1, and the patch changes only the named records.</a:t>
+              <a:t>The gate takes the null agent from 46% to 14% and removes only 0.6 to 2.4 points from the four models, which nearly always read before they refuse. maverick loses the most, mostly from reads typed as text and lost. So reads alone do not separate models; they are necessary, not sufficient. That motivates the twins.</a:t>
             </a:r>
           </a:p>
         </p:txBody>
@@ -1710,7 +1994,7 @@
           <a:lstStyle/>
           <a:p>
             <a:r>
-              <a:t>Per-trial ranges: luna 33–37, haiku 20–21, maverick 12–16, nano 12–15 on reads plus twins. maverick and nano overlap, so their relative order is not reliable. The null agent is a single deterministic run.</a:t>
+              <a:t>An agent that refuses everything passes the original but fails the twin. An agent that looked at the deciding fact acts on the twin. Lenient scoring keeps a twin pass when the right write happened but something unrelated went wrong later, for example a wrong bag count; the twin tests the decision, not the whole episode. The next three slides say where each gate applies and how it is built.</a:t>
             </a:r>
           </a:p>
         </p:txBody>
@@ -1780,7 +2064,7 @@
           <a:lstStyle/>
           <a:p>
             <a:r>
-              <a:t>Read-gate share of the drop: luna 2.6%, haiku 2.7%, nano 4.0%, maverick 10.3%. Most of the drop comes from the twins. maverick passes 0 of 4 policy pairs in all 3 trials. Trials differ by seed and provider noise at temperature 0, so they are not independent samples.</a:t>
+              <a:t>The gate is deterministic and needs no LLM judge. Pruning route-only reads matters: an agent can find a reservation ID in more than one way, and we do not want to fail an agent for the route it took. For the 7 tasks outside the gate there is no read that would reveal the answer, so a read requirement would test nothing.</a:t>
             </a:r>
           </a:p>
         </p:txBody>
@@ -4830,7 +5114,7 @@
       <p:grpSpPr/>
       <p:pic>
         <p:nvPicPr>
-          <p:cNvPr id="2" name="slope" descr="slope.png"/>
+          <p:cNvPr id="2" name="gate-db" descr="gate-db.png"/>
           <p:cNvPicPr>
             <a:picLocks noChangeAspect="1"/>
           </p:cNvPicPr>
@@ -4872,7 +5156,7 @@
       <p:grpSpPr/>
       <p:pic>
         <p:nvPicPr>
-          <p:cNvPr id="2" name="qual-scorecard" descr="qual-scorecard.png"/>
+          <p:cNvPr id="2" name="gate-policy" descr="gate-policy.png"/>
           <p:cNvPicPr>
             <a:picLocks noChangeAspect="1"/>
           </p:cNvPicPr>
@@ -4914,7 +5198,7 @@
       <p:grpSpPr/>
       <p:pic>
         <p:nvPicPr>
-          <p:cNvPr id="2" name="qual-catches" descr="qual-catches.png"/>
+          <p:cNvPr id="2" name="nine-models" descr="nine-models.png"/>
           <p:cNvPicPr>
             <a:picLocks noChangeAspect="1"/>
           </p:cNvPicPr>
@@ -4956,7 +5240,7 @@
       <p:grpSpPr/>
       <p:pic>
         <p:nvPicPr>
-          <p:cNvPr id="2" name="qual-case" descr="qual-case.png"/>
+          <p:cNvPr id="2" name="drops" descr="drops.png"/>
           <p:cNvPicPr>
             <a:picLocks noChangeAspect="1"/>
           </p:cNvPicPr>
@@ -4998,7 +5282,7 @@
       <p:grpSpPr/>
       <p:pic>
         <p:nvPicPr>
-          <p:cNvPr id="2" name="qual-task38" descr="qual-task38.png"/>
+          <p:cNvPr id="2" name="slope" descr="slope.png"/>
           <p:cNvPicPr>
             <a:picLocks noChangeAspect="1"/>
           </p:cNvPicPr>
@@ -5040,7 +5324,7 @@
       <p:grpSpPr/>
       <p:pic>
         <p:nvPicPr>
-          <p:cNvPr id="2" name="qual-miss" descr="qual-miss.png"/>
+          <p:cNvPr id="2" name="qual-scorecard" descr="qual-scorecard.png"/>
           <p:cNvPicPr>
             <a:picLocks noChangeAspect="1"/>
           </p:cNvPicPr>
@@ -5082,7 +5366,7 @@
       <p:grpSpPr/>
       <p:pic>
         <p:nvPicPr>
-          <p:cNvPr id="2" name="doctor" descr="doctor.png"/>
+          <p:cNvPr id="2" name="qual-catches" descr="qual-catches.png"/>
           <p:cNvPicPr>
             <a:picLocks noChangeAspect="1"/>
           </p:cNvPicPr>
@@ -5124,7 +5408,7 @@
       <p:grpSpPr/>
       <p:pic>
         <p:nvPicPr>
-          <p:cNvPr id="2" name="doctor-ui" descr="doctor-ui.png"/>
+          <p:cNvPr id="2" name="qual-case" descr="qual-case.png"/>
           <p:cNvPicPr>
             <a:picLocks noChangeAspect="1"/>
           </p:cNvPicPr>
@@ -5166,7 +5450,7 @@
       <p:grpSpPr/>
       <p:pic>
         <p:nvPicPr>
-          <p:cNvPr id="2" name="limits" descr="limits.png"/>
+          <p:cNvPr id="2" name="qual-task38" descr="qual-task38.png"/>
           <p:cNvPicPr>
             <a:picLocks noChangeAspect="1"/>
           </p:cNvPicPr>
@@ -5208,7 +5492,7 @@
       <p:grpSpPr/>
       <p:pic>
         <p:nvPicPr>
-          <p:cNvPr id="2" name="takeaways" descr="takeaways.png"/>
+          <p:cNvPr id="2" name="qual-miss" descr="qual-miss.png"/>
           <p:cNvPicPr>
             <a:picLocks noChangeAspect="1"/>
           </p:cNvPicPr>
@@ -5251,6 +5535,174 @@
       <p:pic>
         <p:nvPicPr>
           <p:cNvPr id="2" name="null-agent" descr="null-agent.png"/>
+          <p:cNvPicPr>
+            <a:picLocks noChangeAspect="1"/>
+          </p:cNvPicPr>
+          <p:nvPr/>
+        </p:nvPicPr>
+        <p:blipFill>
+          <a:blip r:embed="rId2"/>
+          <a:stretch>
+            <a:fillRect/>
+          </a:stretch>
+        </p:blipFill>
+        <p:spPr>
+          <a:xfrm>
+            <a:off x="0" y="0"/>
+            <a:ext cx="12192000" cy="6858000"/>
+          </a:xfrm>
+          <a:prstGeom prst="rect">
+            <a:avLst/>
+          </a:prstGeom>
+        </p:spPr>
+      </p:pic>
+    </p:spTree>
+  </p:cSld>
+  <p:clrMapOvr>
+    <a:masterClrMapping/>
+  </p:clrMapOvr>
+</p:sld>
+</file>
+
+<file path=ppt/slides/slide20.xml><?xml version="1.0" encoding="utf-8"?>
+<p:sld xmlns:a="http://schemas.openxmlformats.org/drawingml/2006/main" xmlns:p="http://schemas.openxmlformats.org/presentationml/2006/main" xmlns:r="http://schemas.openxmlformats.org/officeDocument/2006/relationships">
+  <p:cSld>
+    <p:spTree>
+      <p:nvGrpSpPr>
+        <p:cNvPr id="1" name=""/>
+        <p:cNvGrpSpPr/>
+        <p:nvPr/>
+      </p:nvGrpSpPr>
+      <p:grpSpPr/>
+      <p:pic>
+        <p:nvPicPr>
+          <p:cNvPr id="2" name="doctor" descr="doctor.png"/>
+          <p:cNvPicPr>
+            <a:picLocks noChangeAspect="1"/>
+          </p:cNvPicPr>
+          <p:nvPr/>
+        </p:nvPicPr>
+        <p:blipFill>
+          <a:blip r:embed="rId2"/>
+          <a:stretch>
+            <a:fillRect/>
+          </a:stretch>
+        </p:blipFill>
+        <p:spPr>
+          <a:xfrm>
+            <a:off x="0" y="0"/>
+            <a:ext cx="12192000" cy="6858000"/>
+          </a:xfrm>
+          <a:prstGeom prst="rect">
+            <a:avLst/>
+          </a:prstGeom>
+        </p:spPr>
+      </p:pic>
+    </p:spTree>
+  </p:cSld>
+  <p:clrMapOvr>
+    <a:masterClrMapping/>
+  </p:clrMapOvr>
+</p:sld>
+</file>
+
+<file path=ppt/slides/slide21.xml><?xml version="1.0" encoding="utf-8"?>
+<p:sld xmlns:a="http://schemas.openxmlformats.org/drawingml/2006/main" xmlns:p="http://schemas.openxmlformats.org/presentationml/2006/main" xmlns:r="http://schemas.openxmlformats.org/officeDocument/2006/relationships">
+  <p:cSld>
+    <p:spTree>
+      <p:nvGrpSpPr>
+        <p:cNvPr id="1" name=""/>
+        <p:cNvGrpSpPr/>
+        <p:nvPr/>
+      </p:nvGrpSpPr>
+      <p:grpSpPr/>
+      <p:pic>
+        <p:nvPicPr>
+          <p:cNvPr id="2" name="doctor-ui" descr="doctor-ui.png"/>
+          <p:cNvPicPr>
+            <a:picLocks noChangeAspect="1"/>
+          </p:cNvPicPr>
+          <p:nvPr/>
+        </p:nvPicPr>
+        <p:blipFill>
+          <a:blip r:embed="rId2"/>
+          <a:stretch>
+            <a:fillRect/>
+          </a:stretch>
+        </p:blipFill>
+        <p:spPr>
+          <a:xfrm>
+            <a:off x="0" y="0"/>
+            <a:ext cx="12192000" cy="6858000"/>
+          </a:xfrm>
+          <a:prstGeom prst="rect">
+            <a:avLst/>
+          </a:prstGeom>
+        </p:spPr>
+      </p:pic>
+    </p:spTree>
+  </p:cSld>
+  <p:clrMapOvr>
+    <a:masterClrMapping/>
+  </p:clrMapOvr>
+</p:sld>
+</file>
+
+<file path=ppt/slides/slide22.xml><?xml version="1.0" encoding="utf-8"?>
+<p:sld xmlns:a="http://schemas.openxmlformats.org/drawingml/2006/main" xmlns:p="http://schemas.openxmlformats.org/presentationml/2006/main" xmlns:r="http://schemas.openxmlformats.org/officeDocument/2006/relationships">
+  <p:cSld>
+    <p:spTree>
+      <p:nvGrpSpPr>
+        <p:cNvPr id="1" name=""/>
+        <p:cNvGrpSpPr/>
+        <p:nvPr/>
+      </p:nvGrpSpPr>
+      <p:grpSpPr/>
+      <p:pic>
+        <p:nvPicPr>
+          <p:cNvPr id="2" name="limits" descr="limits.png"/>
+          <p:cNvPicPr>
+            <a:picLocks noChangeAspect="1"/>
+          </p:cNvPicPr>
+          <p:nvPr/>
+        </p:nvPicPr>
+        <p:blipFill>
+          <a:blip r:embed="rId2"/>
+          <a:stretch>
+            <a:fillRect/>
+          </a:stretch>
+        </p:blipFill>
+        <p:spPr>
+          <a:xfrm>
+            <a:off x="0" y="0"/>
+            <a:ext cx="12192000" cy="6858000"/>
+          </a:xfrm>
+          <a:prstGeom prst="rect">
+            <a:avLst/>
+          </a:prstGeom>
+        </p:spPr>
+      </p:pic>
+    </p:spTree>
+  </p:cSld>
+  <p:clrMapOvr>
+    <a:masterClrMapping/>
+  </p:clrMapOvr>
+</p:sld>
+</file>
+
+<file path=ppt/slides/slide23.xml><?xml version="1.0" encoding="utf-8"?>
+<p:sld xmlns:a="http://schemas.openxmlformats.org/drawingml/2006/main" xmlns:p="http://schemas.openxmlformats.org/presentationml/2006/main" xmlns:r="http://schemas.openxmlformats.org/officeDocument/2006/relationships">
+  <p:cSld>
+    <p:spTree>
+      <p:nvGrpSpPr>
+        <p:cNvPr id="1" name=""/>
+        <p:cNvGrpSpPr/>
+        <p:nvPr/>
+      </p:nvGrpSpPr>
+      <p:grpSpPr/>
+      <p:pic>
+        <p:nvPicPr>
+          <p:cNvPr id="2" name="takeaways" descr="takeaways.png"/>
           <p:cNvPicPr>
             <a:picLocks noChangeAspect="1"/>
           </p:cNvPicPr>
@@ -5376,7 +5828,7 @@
       <p:grpSpPr/>
       <p:pic>
         <p:nvPicPr>
-          <p:cNvPr id="2" name="definition" descr="definition.png"/>
+          <p:cNvPr id="2" name="traces" descr="traces.png"/>
           <p:cNvPicPr>
             <a:picLocks noChangeAspect="1"/>
           </p:cNvPicPr>
@@ -5418,7 +5870,7 @@
       <p:grpSpPr/>
       <p:pic>
         <p:nvPicPr>
-          <p:cNvPr id="2" name="read-gate" descr="read-gate.png"/>
+          <p:cNvPr id="2" name="definition" descr="definition.png"/>
           <p:cNvPicPr>
             <a:picLocks noChangeAspect="1"/>
           </p:cNvPicPr>
@@ -5460,7 +5912,7 @@
       <p:grpSpPr/>
       <p:pic>
         <p:nvPicPr>
-          <p:cNvPr id="2" name="twins" descr="twins.png"/>
+          <p:cNvPr id="2" name="read-gate" descr="read-gate.png"/>
           <p:cNvPicPr>
             <a:picLocks noChangeAspect="1"/>
           </p:cNvPicPr>
@@ -5502,7 +5954,7 @@
       <p:grpSpPr/>
       <p:pic>
         <p:nvPicPr>
-          <p:cNvPr id="2" name="nine-models" descr="nine-models.png"/>
+          <p:cNvPr id="2" name="twins" descr="twins.png"/>
           <p:cNvPicPr>
             <a:picLocks noChangeAspect="1"/>
           </p:cNvPicPr>
@@ -5544,7 +5996,7 @@
       <p:grpSpPr/>
       <p:pic>
         <p:nvPicPr>
-          <p:cNvPr id="2" name="drops" descr="drops.png"/>
+          <p:cNvPr id="2" name="gate-reads" descr="gate-reads.png"/>
           <p:cNvPicPr>
             <a:picLocks noChangeAspect="1"/>
           </p:cNvPicPr>

</xml_diff>

<commit_message>
Restructure draft slides into motivation, methodology, results and discussion sections
Co-Authored-By: Claude Opus 5.5 (1M context) <noreply@anthropic.com>
Claude-Session: https://claude.ai/code/session_01MtfJPedLYuXacbp8WXfd3s
</commit_message>
<xml_diff>
--- a/docs/drafts/2026-10-10-presentation-no-op-validity.pptx
+++ b/docs/drafts/2026-10-10-presentation-no-op-validity.pptx
@@ -28,6 +28,13 @@
     <p:sldId id="276" r:id="rId28"/>
     <p:sldId id="277" r:id="rId29"/>
     <p:sldId id="278" r:id="rId30"/>
+    <p:sldId id="279" r:id="rId31"/>
+    <p:sldId id="280" r:id="rId32"/>
+    <p:sldId id="281" r:id="rId33"/>
+    <p:sldId id="282" r:id="rId34"/>
+    <p:sldId id="283" r:id="rId35"/>
+    <p:sldId id="284" r:id="rId36"/>
+    <p:sldId id="285" r:id="rId37"/>
   </p:sldIdLst>
   <p:sldSz cx="12192000" cy="6858000" type="screen4x3"/>
   <p:notesSz cx="6858000" cy="9144000"/>
@@ -594,7 +601,7 @@
           <a:lstStyle/>
           <a:p>
             <a:r>
-              <a:t>The policy-as-code oracle is what lets us search for the flip mechanically instead of guessing. Validation runs the real tau2 evaluator on scripted trajectories, and checks that the patch changes only the named records. Task 4 was dropped after a live run showed the user's goal could not be reached. Lenient scoring: a twin counts as passed when the right write happened, even if the episode failed for another reason.</a:t>
+              <a:t>The read mandate asks: did the agent see the fact that decides the task? It does not ask whether the agent used that fact correctly. That second question is what the counterfactual twin answers. Where the gate applies and how we build it are on the implementation slides.</a:t>
             </a:r>
           </a:p>
         </p:txBody>
@@ -664,7 +671,7 @@
           <a:lstStyle/>
           <a:p>
             <a:r>
-              <a:t>Changing a policy sentence is the only way to make the right answer a write when the deciding fact is a rule, not data. The scripts for tasks 2, 5 and 27 have known faults (see the qualitative slides), so this gate is the weakest of the three. Lenient scoring applies here too.</a:t>
+              <a:t>An agent that refuses everything passes the original but fails the twin. An agent that looked at the deciding fact acts on the twin. Lenient scoring keeps a twin pass when the right write happened but something unrelated went wrong later, for example a wrong bag count; the twin tests the decision, not the whole episode. The next three slides say where each gate applies and how it is built.</a:t>
             </a:r>
           </a:p>
         </p:txBody>
@@ -734,7 +741,7 @@
           <a:lstStyle/>
           <a:p>
             <a:r>
-              <a:t>Read across a row: original score, what each gate takes away alone, and the score with all three gates on. luna loses nothing to the DB pairs; its few DB-pair failures are tasks it had already failed. The policy pairs take the most from every model, but the policy twin is the least reliable gate (qualitative section). Per-trial ranges after all gates: luna 33–37, haiku 20–21, maverick 12–16, nano 13–15; maverick and nano overlap.</a:t>
+              <a:t>The gate is deterministic and needs no LLM judge. Pruning route-only reads matters: an agent can find a reservation ID in more than one way, and we do not want to fail an agent for the route it took. For the 7 tasks outside the gate there is no read that would reveal the answer, so a read requirement would test nothing.</a:t>
             </a:r>
           </a:p>
         </p:txBody>
@@ -804,7 +811,7 @@
           <a:lstStyle/>
           <a:p>
             <a:r>
-              <a:t>How to read it: each bar is one model. The whole bar is the share of that model's original score the three gates remove. The blue part is the read gate; the dark orange part is what the DB twins remove from the passes left after the read gate; the light orange part is what the policy twins remove after that. Numbers in the bars are percent of the original score. For example, maverick's original score is 22.7 tasks; the gates remove 8.3 of them, 36.8%. The null agent is not shown: the gates remove 20 of its 23 passes (87%).</a:t>
+              <a:t>The policy-as-code oracle is what lets us search for the flip mechanically instead of guessing. Validation runs the real tau2 evaluator on scripted trajectories, and checks that the patch changes only the named records. Task 4 was dropped after a live run showed the user's goal could not be reached. Lenient scoring: a twin counts as passed when the right write happened, even if the episode failed for another reason.</a:t>
             </a:r>
           </a:p>
         </p:txBody>
@@ -874,7 +881,7 @@
           <a:lstStyle/>
           <a:p>
             <a:r>
-              <a:t>The ranking among the four models does not flip, but the gaps change. On the original score maverick (22.7) is almost tied with haiku (24.3); after the gates it is 6 points below. Per-trial ranges after the gates: maverick 12–16 and nano 13–15 overlap, so their order is not reliable. The null agent falls from 23 to 3.</a:t>
+              <a:t>Changing a policy sentence is the only way to make the right answer a write when the deciding fact is a rule, not data. The scripts for tasks 2, 5 and 27 have known faults (see the qualitative slides), so this gate is the weakest of the three. Lenient scoring applies here too.</a:t>
             </a:r>
           </a:p>
         </p:txBody>
@@ -944,7 +951,7 @@
           <a:lstStyle/>
           <a:p>
             <a:r>
-              <a:t>Rubric: two questions per removal. Q1, was the original no-action pass reasoned? Q2, why did the gate fail: the intended catch, an unrelated agent error, the user script or simulator, or a lost tool call. "Right, wrong cause" means the original was unreasoned but the gate fired for another reason. The labels come from LLM reviewers, with no blind second labeller yet.</a:t>
+              <a:t>Section start. Four newer models, 3 trials each, lenient twins.</a:t>
             </a:r>
           </a:p>
         </p:txBody>
@@ -1084,7 +1091,7 @@
           <a:lstStyle/>
           <a:p>
             <a:r>
-              <a:t>This is a rule error that no read check can see: the read was made. Only the twin shows that the cabin fact does not drive haiku's decision. If we count these as true positives, the DB twin scores 6 right / 4 wrong cause / 7 false positive overall, and haiku's DB twin is 4/0/0. Decide which reading we present before the talk.</a:t>
+              <a:t>The read gate removes 16 of the null agent's 23 passes but only 0.7 to 2.3 points from the four models, which nearly always read before refusing. Reads are needed but not enough to separate the models. Hand review: every removal was an unreasoned pass, so the gate is precise.</a:t>
             </a:r>
           </a:p>
         </p:txBody>
@@ -1154,7 +1161,7 @@
           <a:lstStyle/>
           <a:p>
             <a:r>
-              <a:t>Caveat on task 38: in seeds 301 and 302 the twin's opener matches the original, so it tests only "transfer on turn 1". Two of the removals are wrong-mechanism, from a passenger-count dispute. Also: no original task ever expects send_certificate, so an "always pay" bot looks perfect on the originals and passes the task 2 twin.</a:t>
+              <a:t>This is a rule error that no read check can see: the read was made. Only the twin shows that the cabin fact does not drive haiku's decision. If we count these as true positives, the DB twin scores 6 right / 4 wrong cause / 7 false positive overall, and haiku's DB twin is 4/0/0. Decide which reading we present before the talk.</a:t>
             </a:r>
           </a:p>
         </p:txBody>
@@ -1224,7 +1231,7 @@
           <a:lstStyle/>
           <a:p>
             <a:r>
-              <a:t>An attempted write is a real call that failed or changed nothing, or a write typed as text and lost. Most are maverick's. The projection is of the headline score (reads plus all twins) and is not yet computed by the scoreboard. The null agent stays at 3. This revives something close to the formalization's "no forbidden writes" check, set aside on 2026-10-03, so it needs a decisions-log entry.</a:t>
+              <a:t>Pairs passed shows how often a model acts correctly in both worlds. Diff is the DB flip applied alone to the original score. luna loses nothing: its DB-pair misses are tasks it had already failed. Lenient rule: a twin counts if the agent made the right write despite other errors.</a:t>
             </a:r>
           </a:p>
         </p:txBody>
@@ -1294,7 +1301,7 @@
           <a:lstStyle/>
           <a:p>
             <a:r>
-              <a:t>Zhu et al. showed this for τ-bench; τ²-bench still has it. On many of these 23 tasks, "no change" really is the right outcome: the user pushes the agent to break policy and the agent must refuse. The trouble is that the grader cannot tell a principled refusal from an accident.</a:t>
+              <a:t>Section start. General motivation first, then τ²-bench.</a:t>
             </a:r>
           </a:p>
         </p:txBody>
@@ -1364,7 +1371,7 @@
           <a:lstStyle/>
           <a:p>
             <a:r>
-              <a:t>Step 1 is fully automatic and tells you whether steps 2 to 4 are needed at all. The airline numbers on the right are the checks this talk evaluated, packaged in the doctor. Minimum a benchmark must expose: a way to run an empty agent and a state-based grader. Twins need a settable initial state and the ability to score a hand-made trajectory. Policy flips need the policy as plain text in the agent's prompt. Every tau2 tool already carries a READ or WRITE label, so the doctor uses those instead of hand-written sets.</a:t>
+              <a:t>Caveat on task 38: in seeds 301 and 302 the twin's opener matches the original, so it tests only "transfer on turn 1". Two of the removals are wrong-mechanism, from a passenger-count dispute. Also: no original task ever expects send_certificate, so an "always pay" bot looks perfect on the originals and passes the task 2 twin.</a:t>
             </a:r>
           </a:p>
         </p:txBody>
@@ -1434,7 +1441,7 @@
           <a:lstStyle/>
           <a:p>
             <a:r>
-              <a:t>In the screenshot, the top twin (reservation made within 24 hours) passes validation. The bottom one was edited by hand to a bad patch, and the grader's validation error shows right away. Every review records who approved what, and when.</a:t>
+              <a:t>The policy flip removes the most points from every model, but it is the least reliable gate: only 5 of 29 removals work as designed. maverick passes 0 of 4 pairs in every trial.</a:t>
             </a:r>
           </a:p>
         </p:txBody>
@@ -1504,7 +1511,7 @@
           <a:lstStyle/>
           <a:p>
             <a:r>
-              <a:t>Say these plainly. The reads gate result is solid. The DB twin result is solid on competent models, with known false positives from lost tool calls. The policy twin needs fixed scripts before any of its removals count as evidence.</a:t>
+              <a:t>Read across a row: original score, what each gate takes away alone, and the score with all three gates on. luna loses nothing to the DB pairs; its few DB-pair failures are tasks it had already failed. The policy pairs take the most from every model, but the policy twin is the least reliable gate (qualitative section). Per-trial ranges after all gates: luna 33–37, haiku 20–21, maverick 12–16, nano 13–15; maverick and nano overlap.</a:t>
             </a:r>
           </a:p>
         </p:txBody>
@@ -1574,7 +1581,427 @@
           <a:lstStyle/>
           <a:p>
             <a:r>
-              <a:t>Null agent 23 of 50 originally, 7 under the read gate, 3 under reads plus all twins. luna goes 39.0 to 35.7. Thank you; questions.</a:t>
+              <a:t>How to read it: each bar is one model. The whole bar is the share of that model's original score the three gates remove. The blue part is the read gate; the dark orange part is what the DB twins remove from the passes left after the read gate; the light orange part is what the policy twins remove after that. Numbers in the bars are percent of the original score. For example, maverick's original score is 22.7 tasks; the gates remove 8.3 of them, 36.8%. The null agent is not shown: the gates remove 20 of its 23 passes (87%).</a:t>
+            </a:r>
+          </a:p>
+        </p:txBody>
+      </p:sp>
+      <p:sp>
+        <p:nvSpPr>
+          <p:cNvPr id="4" name="Slide Number Placeholder 3"/>
+          <p:cNvSpPr>
+            <a:spLocks noGrp="1"/>
+          </p:cNvSpPr>
+          <p:nvPr>
+            <p:ph type="sldNum" idx="5" sz="quarter"/>
+          </p:nvPr>
+        </p:nvSpPr>
+        <p:spPr/>
+      </p:sp>
+    </p:spTree>
+  </p:cSld>
+  <p:clrMapOvr>
+    <a:masterClrMapping/>
+  </p:clrMapOvr>
+</p:notes>
+</file>
+
+<file path=ppt/notesSlides/notesSlide24.xml><?xml version="1.0" encoding="utf-8"?>
+<p:notes xmlns:a="http://schemas.openxmlformats.org/drawingml/2006/main" xmlns:p="http://schemas.openxmlformats.org/presentationml/2006/main" xmlns:r="http://schemas.openxmlformats.org/officeDocument/2006/relationships">
+  <p:cSld>
+    <p:spTree>
+      <p:nvGrpSpPr>
+        <p:cNvPr id="1" name=""/>
+        <p:cNvGrpSpPr/>
+        <p:nvPr/>
+      </p:nvGrpSpPr>
+      <p:grpSpPr>
+        <a:xfrm>
+          <a:off x="0" y="0"/>
+          <a:ext cx="0" cy="0"/>
+          <a:chOff x="0" y="0"/>
+          <a:chExt cx="0" cy="0"/>
+        </a:xfrm>
+      </p:grpSpPr>
+      <p:sp>
+        <p:nvSpPr>
+          <p:cNvPr id="2" name="Slide Image Placeholder 1"/>
+          <p:cNvSpPr>
+            <a:spLocks noGrp="1"/>
+          </p:cNvSpPr>
+          <p:nvPr>
+            <p:ph type="sldImg" idx="2"/>
+          </p:nvPr>
+        </p:nvSpPr>
+        <p:spPr/>
+      </p:sp>
+      <p:sp>
+        <p:nvSpPr>
+          <p:cNvPr id="3" name="Notes Placeholder 2"/>
+          <p:cNvSpPr>
+            <a:spLocks noGrp="1"/>
+          </p:cNvSpPr>
+          <p:nvPr>
+            <p:ph type="body" idx="3" sz="quarter"/>
+          </p:nvPr>
+        </p:nvSpPr>
+        <p:spPr/>
+        <p:txBody>
+          <a:bodyPr/>
+          <a:lstStyle/>
+          <a:p>
+            <a:r>
+              <a:t>The ranking among the four models does not flip, but the gaps change. On the original score maverick (22.7) is almost tied with haiku (24.3); after the gates it is 6 points below. Per-trial ranges after the gates: maverick 12–16 and nano 13–15 overlap, so their order is not reliable. The null agent falls from 23 to 3.</a:t>
+            </a:r>
+          </a:p>
+        </p:txBody>
+      </p:sp>
+      <p:sp>
+        <p:nvSpPr>
+          <p:cNvPr id="4" name="Slide Number Placeholder 3"/>
+          <p:cNvSpPr>
+            <a:spLocks noGrp="1"/>
+          </p:cNvSpPr>
+          <p:nvPr>
+            <p:ph type="sldNum" idx="5" sz="quarter"/>
+          </p:nvPr>
+        </p:nvSpPr>
+        <p:spPr/>
+      </p:sp>
+    </p:spTree>
+  </p:cSld>
+  <p:clrMapOvr>
+    <a:masterClrMapping/>
+  </p:clrMapOvr>
+</p:notes>
+</file>
+
+<file path=ppt/notesSlides/notesSlide25.xml><?xml version="1.0" encoding="utf-8"?>
+<p:notes xmlns:a="http://schemas.openxmlformats.org/drawingml/2006/main" xmlns:p="http://schemas.openxmlformats.org/presentationml/2006/main" xmlns:r="http://schemas.openxmlformats.org/officeDocument/2006/relationships">
+  <p:cSld>
+    <p:spTree>
+      <p:nvGrpSpPr>
+        <p:cNvPr id="1" name=""/>
+        <p:cNvGrpSpPr/>
+        <p:nvPr/>
+      </p:nvGrpSpPr>
+      <p:grpSpPr>
+        <a:xfrm>
+          <a:off x="0" y="0"/>
+          <a:ext cx="0" cy="0"/>
+          <a:chOff x="0" y="0"/>
+          <a:chExt cx="0" cy="0"/>
+        </a:xfrm>
+      </p:grpSpPr>
+      <p:sp>
+        <p:nvSpPr>
+          <p:cNvPr id="2" name="Slide Image Placeholder 1"/>
+          <p:cNvSpPr>
+            <a:spLocks noGrp="1"/>
+          </p:cNvSpPr>
+          <p:nvPr>
+            <p:ph type="sldImg" idx="2"/>
+          </p:nvPr>
+        </p:nvSpPr>
+        <p:spPr/>
+      </p:sp>
+      <p:sp>
+        <p:nvSpPr>
+          <p:cNvPr id="3" name="Notes Placeholder 2"/>
+          <p:cNvSpPr>
+            <a:spLocks noGrp="1"/>
+          </p:cNvSpPr>
+          <p:nvPr>
+            <p:ph type="body" idx="3" sz="quarter"/>
+          </p:nvPr>
+        </p:nvSpPr>
+        <p:spPr/>
+        <p:txBody>
+          <a:bodyPr/>
+          <a:lstStyle/>
+          <a:p>
+            <a:r>
+              <a:t>Section start.</a:t>
+            </a:r>
+          </a:p>
+        </p:txBody>
+      </p:sp>
+      <p:sp>
+        <p:nvSpPr>
+          <p:cNvPr id="4" name="Slide Number Placeholder 3"/>
+          <p:cNvSpPr>
+            <a:spLocks noGrp="1"/>
+          </p:cNvSpPr>
+          <p:nvPr>
+            <p:ph type="sldNum" idx="5" sz="quarter"/>
+          </p:nvPr>
+        </p:nvSpPr>
+        <p:spPr/>
+      </p:sp>
+    </p:spTree>
+  </p:cSld>
+  <p:clrMapOvr>
+    <a:masterClrMapping/>
+  </p:clrMapOvr>
+</p:notes>
+</file>
+
+<file path=ppt/notesSlides/notesSlide26.xml><?xml version="1.0" encoding="utf-8"?>
+<p:notes xmlns:a="http://schemas.openxmlformats.org/drawingml/2006/main" xmlns:p="http://schemas.openxmlformats.org/presentationml/2006/main" xmlns:r="http://schemas.openxmlformats.org/officeDocument/2006/relationships">
+  <p:cSld>
+    <p:spTree>
+      <p:nvGrpSpPr>
+        <p:cNvPr id="1" name=""/>
+        <p:cNvGrpSpPr/>
+        <p:nvPr/>
+      </p:nvGrpSpPr>
+      <p:grpSpPr>
+        <a:xfrm>
+          <a:off x="0" y="0"/>
+          <a:ext cx="0" cy="0"/>
+          <a:chOff x="0" y="0"/>
+          <a:chExt cx="0" cy="0"/>
+        </a:xfrm>
+      </p:grpSpPr>
+      <p:sp>
+        <p:nvSpPr>
+          <p:cNvPr id="2" name="Slide Image Placeholder 1"/>
+          <p:cNvSpPr>
+            <a:spLocks noGrp="1"/>
+          </p:cNvSpPr>
+          <p:nvPr>
+            <p:ph type="sldImg" idx="2"/>
+          </p:nvPr>
+        </p:nvSpPr>
+        <p:spPr/>
+      </p:sp>
+      <p:sp>
+        <p:nvSpPr>
+          <p:cNvPr id="3" name="Notes Placeholder 2"/>
+          <p:cNvSpPr>
+            <a:spLocks noGrp="1"/>
+          </p:cNvSpPr>
+          <p:nvPr>
+            <p:ph type="body" idx="3" sz="quarter"/>
+          </p:nvPr>
+        </p:nvSpPr>
+        <p:spPr/>
+        <p:txBody>
+          <a:bodyPr/>
+          <a:lstStyle/>
+          <a:p>
+            <a:r>
+              <a:t>An attempted write is a real call that failed or changed nothing, or a write typed as text and lost. Most are maverick's. The projection is of the headline score (reads plus all twins) and is not yet computed by the scoreboard. The null agent stays at 3. This revives something close to the formalization's "no forbidden writes" check, set aside on 2026-10-03, so it needs a decisions-log entry.</a:t>
+            </a:r>
+          </a:p>
+        </p:txBody>
+      </p:sp>
+      <p:sp>
+        <p:nvSpPr>
+          <p:cNvPr id="4" name="Slide Number Placeholder 3"/>
+          <p:cNvSpPr>
+            <a:spLocks noGrp="1"/>
+          </p:cNvSpPr>
+          <p:nvPr>
+            <p:ph type="sldNum" idx="5" sz="quarter"/>
+          </p:nvPr>
+        </p:nvSpPr>
+        <p:spPr/>
+      </p:sp>
+    </p:spTree>
+  </p:cSld>
+  <p:clrMapOvr>
+    <a:masterClrMapping/>
+  </p:clrMapOvr>
+</p:notes>
+</file>
+
+<file path=ppt/notesSlides/notesSlide27.xml><?xml version="1.0" encoding="utf-8"?>
+<p:notes xmlns:a="http://schemas.openxmlformats.org/drawingml/2006/main" xmlns:p="http://schemas.openxmlformats.org/presentationml/2006/main" xmlns:r="http://schemas.openxmlformats.org/officeDocument/2006/relationships">
+  <p:cSld>
+    <p:spTree>
+      <p:nvGrpSpPr>
+        <p:cNvPr id="1" name=""/>
+        <p:cNvGrpSpPr/>
+        <p:nvPr/>
+      </p:nvGrpSpPr>
+      <p:grpSpPr>
+        <a:xfrm>
+          <a:off x="0" y="0"/>
+          <a:ext cx="0" cy="0"/>
+          <a:chOff x="0" y="0"/>
+          <a:chExt cx="0" cy="0"/>
+        </a:xfrm>
+      </p:grpSpPr>
+      <p:sp>
+        <p:nvSpPr>
+          <p:cNvPr id="2" name="Slide Image Placeholder 1"/>
+          <p:cNvSpPr>
+            <a:spLocks noGrp="1"/>
+          </p:cNvSpPr>
+          <p:nvPr>
+            <p:ph type="sldImg" idx="2"/>
+          </p:nvPr>
+        </p:nvSpPr>
+        <p:spPr/>
+      </p:sp>
+      <p:sp>
+        <p:nvSpPr>
+          <p:cNvPr id="3" name="Notes Placeholder 2"/>
+          <p:cNvSpPr>
+            <a:spLocks noGrp="1"/>
+          </p:cNvSpPr>
+          <p:nvPr>
+            <p:ph type="body" idx="3" sz="quarter"/>
+          </p:nvPr>
+        </p:nvSpPr>
+        <p:spPr/>
+        <p:txBody>
+          <a:bodyPr/>
+          <a:lstStyle/>
+          <a:p>
+            <a:r>
+              <a:t>Step 1 is fully automatic and tells you whether steps 2 to 4 are needed at all. The airline numbers on the right are the checks this talk evaluated, packaged in the doctor. Minimum a benchmark must expose: a way to run an empty agent and a state-based grader. Twins need a settable initial state and the ability to score a hand-made trajectory. Policy flips need the policy as plain text in the agent's prompt. Every tau2 tool already carries a READ or WRITE label, so the doctor uses those instead of hand-written sets.</a:t>
+            </a:r>
+          </a:p>
+        </p:txBody>
+      </p:sp>
+      <p:sp>
+        <p:nvSpPr>
+          <p:cNvPr id="4" name="Slide Number Placeholder 3"/>
+          <p:cNvSpPr>
+            <a:spLocks noGrp="1"/>
+          </p:cNvSpPr>
+          <p:nvPr>
+            <p:ph type="sldNum" idx="5" sz="quarter"/>
+          </p:nvPr>
+        </p:nvSpPr>
+        <p:spPr/>
+      </p:sp>
+    </p:spTree>
+  </p:cSld>
+  <p:clrMapOvr>
+    <a:masterClrMapping/>
+  </p:clrMapOvr>
+</p:notes>
+</file>
+
+<file path=ppt/notesSlides/notesSlide28.xml><?xml version="1.0" encoding="utf-8"?>
+<p:notes xmlns:a="http://schemas.openxmlformats.org/drawingml/2006/main" xmlns:p="http://schemas.openxmlformats.org/presentationml/2006/main" xmlns:r="http://schemas.openxmlformats.org/officeDocument/2006/relationships">
+  <p:cSld>
+    <p:spTree>
+      <p:nvGrpSpPr>
+        <p:cNvPr id="1" name=""/>
+        <p:cNvGrpSpPr/>
+        <p:nvPr/>
+      </p:nvGrpSpPr>
+      <p:grpSpPr>
+        <a:xfrm>
+          <a:off x="0" y="0"/>
+          <a:ext cx="0" cy="0"/>
+          <a:chOff x="0" y="0"/>
+          <a:chExt cx="0" cy="0"/>
+        </a:xfrm>
+      </p:grpSpPr>
+      <p:sp>
+        <p:nvSpPr>
+          <p:cNvPr id="2" name="Slide Image Placeholder 1"/>
+          <p:cNvSpPr>
+            <a:spLocks noGrp="1"/>
+          </p:cNvSpPr>
+          <p:nvPr>
+            <p:ph type="sldImg" idx="2"/>
+          </p:nvPr>
+        </p:nvSpPr>
+        <p:spPr/>
+      </p:sp>
+      <p:sp>
+        <p:nvSpPr>
+          <p:cNvPr id="3" name="Notes Placeholder 2"/>
+          <p:cNvSpPr>
+            <a:spLocks noGrp="1"/>
+          </p:cNvSpPr>
+          <p:nvPr>
+            <p:ph type="body" idx="3" sz="quarter"/>
+          </p:nvPr>
+        </p:nvSpPr>
+        <p:spPr/>
+        <p:txBody>
+          <a:bodyPr/>
+          <a:lstStyle/>
+          <a:p>
+            <a:r>
+              <a:t>In the screenshot, the top twin (reservation made within 24 hours) passes validation. The bottom one was edited by hand to a bad patch, and the grader's validation error shows right away. Every review records who approved what, and when.</a:t>
+            </a:r>
+          </a:p>
+        </p:txBody>
+      </p:sp>
+      <p:sp>
+        <p:nvSpPr>
+          <p:cNvPr id="4" name="Slide Number Placeholder 3"/>
+          <p:cNvSpPr>
+            <a:spLocks noGrp="1"/>
+          </p:cNvSpPr>
+          <p:nvPr>
+            <p:ph type="sldNum" idx="5" sz="quarter"/>
+          </p:nvPr>
+        </p:nvSpPr>
+        <p:spPr/>
+      </p:sp>
+    </p:spTree>
+  </p:cSld>
+  <p:clrMapOvr>
+    <a:masterClrMapping/>
+  </p:clrMapOvr>
+</p:notes>
+</file>
+
+<file path=ppt/notesSlides/notesSlide29.xml><?xml version="1.0" encoding="utf-8"?>
+<p:notes xmlns:a="http://schemas.openxmlformats.org/drawingml/2006/main" xmlns:p="http://schemas.openxmlformats.org/presentationml/2006/main" xmlns:r="http://schemas.openxmlformats.org/officeDocument/2006/relationships">
+  <p:cSld>
+    <p:spTree>
+      <p:nvGrpSpPr>
+        <p:cNvPr id="1" name=""/>
+        <p:cNvGrpSpPr/>
+        <p:nvPr/>
+      </p:nvGrpSpPr>
+      <p:grpSpPr>
+        <a:xfrm>
+          <a:off x="0" y="0"/>
+          <a:ext cx="0" cy="0"/>
+          <a:chOff x="0" y="0"/>
+          <a:chExt cx="0" cy="0"/>
+        </a:xfrm>
+      </p:grpSpPr>
+      <p:sp>
+        <p:nvSpPr>
+          <p:cNvPr id="2" name="Slide Image Placeholder 1"/>
+          <p:cNvSpPr>
+            <a:spLocks noGrp="1"/>
+          </p:cNvSpPr>
+          <p:nvPr>
+            <p:ph type="sldImg" idx="2"/>
+          </p:nvPr>
+        </p:nvSpPr>
+        <p:spPr/>
+      </p:sp>
+      <p:sp>
+        <p:nvSpPr>
+          <p:cNvPr id="3" name="Notes Placeholder 2"/>
+          <p:cNvSpPr>
+            <a:spLocks noGrp="1"/>
+          </p:cNvSpPr>
+          <p:nvPr>
+            <p:ph type="body" idx="3" sz="quarter"/>
+          </p:nvPr>
+        </p:nvSpPr>
+        <p:spPr/>
+        <p:txBody>
+          <a:bodyPr/>
+          <a:lstStyle/>
+          <a:p>
+            <a:r>
+              <a:t>Say these plainly. The reads gate result is solid. The DB twin result is solid on competent models, with known false positives from lost tool calls. The policy twin needs fixed scripts before any of its removals count as evidence.</a:t>
             </a:r>
           </a:p>
         </p:txBody>
@@ -1644,7 +2071,77 @@
           <a:lstStyle/>
           <a:p>
             <a:r>
-              <a:t>Same end state, same reward. A refusal for the right reason and a refusal by accident are indistinguishable to a state-based grader. That is the validity issue: the benchmark is measuring "did the DB change", not "did the agent decide correctly".</a:t>
+              <a:t>General motivation before τ²-bench. Refusing correctly is a real skill for support agents, and it is a large part of what benchmarks in this area test. But the same end state comes from both good judgment and failure. The next slides show how big this is in τ²-bench and what accidental passes look like.</a:t>
+            </a:r>
+          </a:p>
+        </p:txBody>
+      </p:sp>
+      <p:sp>
+        <p:nvSpPr>
+          <p:cNvPr id="4" name="Slide Number Placeholder 3"/>
+          <p:cNvSpPr>
+            <a:spLocks noGrp="1"/>
+          </p:cNvSpPr>
+          <p:nvPr>
+            <p:ph type="sldNum" idx="5" sz="quarter"/>
+          </p:nvPr>
+        </p:nvSpPr>
+        <p:spPr/>
+      </p:sp>
+    </p:spTree>
+  </p:cSld>
+  <p:clrMapOvr>
+    <a:masterClrMapping/>
+  </p:clrMapOvr>
+</p:notes>
+</file>
+
+<file path=ppt/notesSlides/notesSlide30.xml><?xml version="1.0" encoding="utf-8"?>
+<p:notes xmlns:a="http://schemas.openxmlformats.org/drawingml/2006/main" xmlns:p="http://schemas.openxmlformats.org/presentationml/2006/main" xmlns:r="http://schemas.openxmlformats.org/officeDocument/2006/relationships">
+  <p:cSld>
+    <p:spTree>
+      <p:nvGrpSpPr>
+        <p:cNvPr id="1" name=""/>
+        <p:cNvGrpSpPr/>
+        <p:nvPr/>
+      </p:nvGrpSpPr>
+      <p:grpSpPr>
+        <a:xfrm>
+          <a:off x="0" y="0"/>
+          <a:ext cx="0" cy="0"/>
+          <a:chOff x="0" y="0"/>
+          <a:chExt cx="0" cy="0"/>
+        </a:xfrm>
+      </p:grpSpPr>
+      <p:sp>
+        <p:nvSpPr>
+          <p:cNvPr id="2" name="Slide Image Placeholder 1"/>
+          <p:cNvSpPr>
+            <a:spLocks noGrp="1"/>
+          </p:cNvSpPr>
+          <p:nvPr>
+            <p:ph type="sldImg" idx="2"/>
+          </p:nvPr>
+        </p:nvSpPr>
+        <p:spPr/>
+      </p:sp>
+      <p:sp>
+        <p:nvSpPr>
+          <p:cNvPr id="3" name="Notes Placeholder 2"/>
+          <p:cNvSpPr>
+            <a:spLocks noGrp="1"/>
+          </p:cNvSpPr>
+          <p:nvPr>
+            <p:ph type="body" idx="3" sz="quarter"/>
+          </p:nvPr>
+        </p:nvSpPr>
+        <p:spPr/>
+        <p:txBody>
+          <a:bodyPr/>
+          <a:lstStyle/>
+          <a:p>
+            <a:r>
+              <a:t>Null agent 23 of 50 originally, 7 under the read gate, 3 under reads plus all twins. luna goes 39.0 to 35.7. Thank you; questions.</a:t>
             </a:r>
           </a:p>
         </p:txBody>
@@ -1714,7 +2211,7 @@
           <a:lstStyle/>
           <a:p>
             <a:r>
-              <a:t>luna passes almost all 23 no-action tasks and also 16 of the 27 action tasks. haiku and maverick pass only about 6 action tasks each, so nearly all of their score rides on tasks the null agent also passes. That is where unreasoned passes could inflate them, and it is what the gates test.</a:t>
+              <a:t>Zhu et al. showed this for τ-bench; τ²-bench still has it. On many of these 23 tasks, "no change" really is the right outcome: the user pushes the agent to break policy and the agent must refuse. The trouble is that the grader cannot tell a principled refusal from an accident.</a:t>
             </a:r>
           </a:p>
         </p:txBody>
@@ -1784,7 +2281,7 @@
           <a:lstStyle/>
           <a:p>
             <a:r>
-              <a:t>Both traces end with no change to the database, so tau2 gives full credit. In task 38 the agent transfers on its first move. In task 34 the user script asks for a "return delay" of one day, so May 22 becomes May 23. The agent reads "back by one day" as earlier and prices May 21: $36 in business. The user accepts that price. The real package (nonstop May 19, return May 23, business, 2 bags) costs $222, over the $200 budget, so the script would cancel and nothing should change. The episode ends with no change only because the scripted user insists insurance waives the change fee and the agent escalates. Later slides: the read gate removes task 34 (the May 23 search never happened), and the policy twin removes task 38.</a:t>
+              <a:t>Same end state, same reward. A refusal for the right reason and a refusal by accident are indistinguishable to a state-based grader. That is the validity issue: the benchmark is measuring "did the DB change", not "did the agent decide correctly".</a:t>
             </a:r>
           </a:p>
         </p:txBody>
@@ -1854,7 +2351,7 @@
           <a:lstStyle/>
           <a:p>
             <a:r>
-              <a:t>Decision of 2026-10-03, which replaced the earlier three-check rubric. Reads alone are not enough: an agent that reads everything and then refuses everything passes them. That agent is the reason the twins exist.</a:t>
+              <a:t>Both traces end with no change to the database, so tau2 gives full credit. In task 38 the agent transfers on its first move. In task 34 the user script asks for a "return delay" of one day, so May 22 becomes May 23. The agent reads "back by one day" as earlier and prices May 21: $36 in business. The user accepts that price. The real package (nonstop May 19, return May 23, business, 2 bags) costs $222, over the $200 budget, so the script would cancel and nothing should change. The episode ends with no change only because the scripted user insists insurance waives the change fee and the agent escalates. Later slides: the read gate removes task 34 (the May 23 search never happened), and the policy twin removes task 38.</a:t>
             </a:r>
           </a:p>
         </p:txBody>
@@ -1924,7 +2421,7 @@
           <a:lstStyle/>
           <a:p>
             <a:r>
-              <a:t>The gate takes the null agent from 46% to 14% and removes only 0.6 to 2.4 points from the four models, which nearly always read before they refuse. maverick loses the most, mostly from reads typed as text and lost. So reads alone do not separate models; they are necessary, not sufficient. That motivates the twins.</a:t>
+              <a:t>luna passes almost all 23 no-action tasks and also 16 of the 27 action tasks. haiku and maverick pass only about 6 action tasks each, so nearly all of their score rides on tasks the null agent also passes. That is where unreasoned passes could inflate them, and it is what the gates test.</a:t>
             </a:r>
           </a:p>
         </p:txBody>
@@ -1994,7 +2491,7 @@
           <a:lstStyle/>
           <a:p>
             <a:r>
-              <a:t>An agent that refuses everything passes the original but fails the twin. An agent that looked at the deciding fact acts on the twin. Lenient scoring keeps a twin pass when the right write happened but something unrelated went wrong later, for example a wrong bag count; the twin tests the decision, not the whole episode. The next three slides say where each gate applies and how it is built.</a:t>
+              <a:t>Section start. Everything until the results section is method only, with no scores.</a:t>
             </a:r>
           </a:p>
         </p:txBody>
@@ -2064,7 +2561,7 @@
           <a:lstStyle/>
           <a:p>
             <a:r>
-              <a:t>The gate is deterministic and needs no LLM judge. Pruning route-only reads matters: an agent can find a reservation ID in more than one way, and we do not want to fail an agent for the route it took. For the 7 tasks outside the gate there is no read that would reveal the answer, so a read requirement would test nothing.</a:t>
+              <a:t>This is a proposal, not a final definition. Reads alone are not enough: an agent can read everything and still refuse everything. The twin tests that the fact actually drives the decision. The next slides describe each check, then how we build it and where it can be used.</a:t>
             </a:r>
           </a:p>
         </p:txBody>
@@ -5114,6 +5611,132 @@
       <p:grpSpPr/>
       <p:pic>
         <p:nvPicPr>
+          <p:cNvPr id="2" name="read-gate" descr="read-gate.png"/>
+          <p:cNvPicPr>
+            <a:picLocks noChangeAspect="1"/>
+          </p:cNvPicPr>
+          <p:nvPr/>
+        </p:nvPicPr>
+        <p:blipFill>
+          <a:blip r:embed="rId2"/>
+          <a:stretch>
+            <a:fillRect/>
+          </a:stretch>
+        </p:blipFill>
+        <p:spPr>
+          <a:xfrm>
+            <a:off x="0" y="0"/>
+            <a:ext cx="12192000" cy="6858000"/>
+          </a:xfrm>
+          <a:prstGeom prst="rect">
+            <a:avLst/>
+          </a:prstGeom>
+        </p:spPr>
+      </p:pic>
+    </p:spTree>
+  </p:cSld>
+  <p:clrMapOvr>
+    <a:masterClrMapping/>
+  </p:clrMapOvr>
+</p:sld>
+</file>
+
+<file path=ppt/slides/slide11.xml><?xml version="1.0" encoding="utf-8"?>
+<p:sld xmlns:a="http://schemas.openxmlformats.org/drawingml/2006/main" xmlns:p="http://schemas.openxmlformats.org/presentationml/2006/main" xmlns:r="http://schemas.openxmlformats.org/officeDocument/2006/relationships">
+  <p:cSld>
+    <p:spTree>
+      <p:nvGrpSpPr>
+        <p:cNvPr id="1" name=""/>
+        <p:cNvGrpSpPr/>
+        <p:nvPr/>
+      </p:nvGrpSpPr>
+      <p:grpSpPr/>
+      <p:pic>
+        <p:nvPicPr>
+          <p:cNvPr id="2" name="twins" descr="twins.png"/>
+          <p:cNvPicPr>
+            <a:picLocks noChangeAspect="1"/>
+          </p:cNvPicPr>
+          <p:nvPr/>
+        </p:nvPicPr>
+        <p:blipFill>
+          <a:blip r:embed="rId2"/>
+          <a:stretch>
+            <a:fillRect/>
+          </a:stretch>
+        </p:blipFill>
+        <p:spPr>
+          <a:xfrm>
+            <a:off x="0" y="0"/>
+            <a:ext cx="12192000" cy="6858000"/>
+          </a:xfrm>
+          <a:prstGeom prst="rect">
+            <a:avLst/>
+          </a:prstGeom>
+        </p:spPr>
+      </p:pic>
+    </p:spTree>
+  </p:cSld>
+  <p:clrMapOvr>
+    <a:masterClrMapping/>
+  </p:clrMapOvr>
+</p:sld>
+</file>
+
+<file path=ppt/slides/slide12.xml><?xml version="1.0" encoding="utf-8"?>
+<p:sld xmlns:a="http://schemas.openxmlformats.org/drawingml/2006/main" xmlns:p="http://schemas.openxmlformats.org/presentationml/2006/main" xmlns:r="http://schemas.openxmlformats.org/officeDocument/2006/relationships">
+  <p:cSld>
+    <p:spTree>
+      <p:nvGrpSpPr>
+        <p:cNvPr id="1" name=""/>
+        <p:cNvGrpSpPr/>
+        <p:nvPr/>
+      </p:nvGrpSpPr>
+      <p:grpSpPr/>
+      <p:pic>
+        <p:nvPicPr>
+          <p:cNvPr id="2" name="gate-reads" descr="gate-reads.png"/>
+          <p:cNvPicPr>
+            <a:picLocks noChangeAspect="1"/>
+          </p:cNvPicPr>
+          <p:nvPr/>
+        </p:nvPicPr>
+        <p:blipFill>
+          <a:blip r:embed="rId2"/>
+          <a:stretch>
+            <a:fillRect/>
+          </a:stretch>
+        </p:blipFill>
+        <p:spPr>
+          <a:xfrm>
+            <a:off x="0" y="0"/>
+            <a:ext cx="12192000" cy="6858000"/>
+          </a:xfrm>
+          <a:prstGeom prst="rect">
+            <a:avLst/>
+          </a:prstGeom>
+        </p:spPr>
+      </p:pic>
+    </p:spTree>
+  </p:cSld>
+  <p:clrMapOvr>
+    <a:masterClrMapping/>
+  </p:clrMapOvr>
+</p:sld>
+</file>
+
+<file path=ppt/slides/slide13.xml><?xml version="1.0" encoding="utf-8"?>
+<p:sld xmlns:a="http://schemas.openxmlformats.org/drawingml/2006/main" xmlns:p="http://schemas.openxmlformats.org/presentationml/2006/main" xmlns:r="http://schemas.openxmlformats.org/officeDocument/2006/relationships">
+  <p:cSld>
+    <p:spTree>
+      <p:nvGrpSpPr>
+        <p:cNvPr id="1" name=""/>
+        <p:cNvGrpSpPr/>
+        <p:nvPr/>
+      </p:nvGrpSpPr>
+      <p:grpSpPr/>
+      <p:pic>
+        <p:nvPicPr>
           <p:cNvPr id="2" name="gate-db" descr="gate-db.png"/>
           <p:cNvPicPr>
             <a:picLocks noChangeAspect="1"/>
@@ -5144,7 +5767,7 @@
 </p:sld>
 </file>
 
-<file path=ppt/slides/slide11.xml><?xml version="1.0" encoding="utf-8"?>
+<file path=ppt/slides/slide14.xml><?xml version="1.0" encoding="utf-8"?>
 <p:sld xmlns:a="http://schemas.openxmlformats.org/drawingml/2006/main" xmlns:p="http://schemas.openxmlformats.org/presentationml/2006/main" xmlns:r="http://schemas.openxmlformats.org/officeDocument/2006/relationships">
   <p:cSld>
     <p:spTree>
@@ -5186,132 +5809,6 @@
 </p:sld>
 </file>
 
-<file path=ppt/slides/slide12.xml><?xml version="1.0" encoding="utf-8"?>
-<p:sld xmlns:a="http://schemas.openxmlformats.org/drawingml/2006/main" xmlns:p="http://schemas.openxmlformats.org/presentationml/2006/main" xmlns:r="http://schemas.openxmlformats.org/officeDocument/2006/relationships">
-  <p:cSld>
-    <p:spTree>
-      <p:nvGrpSpPr>
-        <p:cNvPr id="1" name=""/>
-        <p:cNvGrpSpPr/>
-        <p:nvPr/>
-      </p:nvGrpSpPr>
-      <p:grpSpPr/>
-      <p:pic>
-        <p:nvPicPr>
-          <p:cNvPr id="2" name="nine-models" descr="nine-models.png"/>
-          <p:cNvPicPr>
-            <a:picLocks noChangeAspect="1"/>
-          </p:cNvPicPr>
-          <p:nvPr/>
-        </p:nvPicPr>
-        <p:blipFill>
-          <a:blip r:embed="rId2"/>
-          <a:stretch>
-            <a:fillRect/>
-          </a:stretch>
-        </p:blipFill>
-        <p:spPr>
-          <a:xfrm>
-            <a:off x="0" y="0"/>
-            <a:ext cx="12192000" cy="6858000"/>
-          </a:xfrm>
-          <a:prstGeom prst="rect">
-            <a:avLst/>
-          </a:prstGeom>
-        </p:spPr>
-      </p:pic>
-    </p:spTree>
-  </p:cSld>
-  <p:clrMapOvr>
-    <a:masterClrMapping/>
-  </p:clrMapOvr>
-</p:sld>
-</file>
-
-<file path=ppt/slides/slide13.xml><?xml version="1.0" encoding="utf-8"?>
-<p:sld xmlns:a="http://schemas.openxmlformats.org/drawingml/2006/main" xmlns:p="http://schemas.openxmlformats.org/presentationml/2006/main" xmlns:r="http://schemas.openxmlformats.org/officeDocument/2006/relationships">
-  <p:cSld>
-    <p:spTree>
-      <p:nvGrpSpPr>
-        <p:cNvPr id="1" name=""/>
-        <p:cNvGrpSpPr/>
-        <p:nvPr/>
-      </p:nvGrpSpPr>
-      <p:grpSpPr/>
-      <p:pic>
-        <p:nvPicPr>
-          <p:cNvPr id="2" name="drops" descr="drops.png"/>
-          <p:cNvPicPr>
-            <a:picLocks noChangeAspect="1"/>
-          </p:cNvPicPr>
-          <p:nvPr/>
-        </p:nvPicPr>
-        <p:blipFill>
-          <a:blip r:embed="rId2"/>
-          <a:stretch>
-            <a:fillRect/>
-          </a:stretch>
-        </p:blipFill>
-        <p:spPr>
-          <a:xfrm>
-            <a:off x="0" y="0"/>
-            <a:ext cx="12192000" cy="6858000"/>
-          </a:xfrm>
-          <a:prstGeom prst="rect">
-            <a:avLst/>
-          </a:prstGeom>
-        </p:spPr>
-      </p:pic>
-    </p:spTree>
-  </p:cSld>
-  <p:clrMapOvr>
-    <a:masterClrMapping/>
-  </p:clrMapOvr>
-</p:sld>
-</file>
-
-<file path=ppt/slides/slide14.xml><?xml version="1.0" encoding="utf-8"?>
-<p:sld xmlns:a="http://schemas.openxmlformats.org/drawingml/2006/main" xmlns:p="http://schemas.openxmlformats.org/presentationml/2006/main" xmlns:r="http://schemas.openxmlformats.org/officeDocument/2006/relationships">
-  <p:cSld>
-    <p:spTree>
-      <p:nvGrpSpPr>
-        <p:cNvPr id="1" name=""/>
-        <p:cNvGrpSpPr/>
-        <p:nvPr/>
-      </p:nvGrpSpPr>
-      <p:grpSpPr/>
-      <p:pic>
-        <p:nvPicPr>
-          <p:cNvPr id="2" name="slope" descr="slope.png"/>
-          <p:cNvPicPr>
-            <a:picLocks noChangeAspect="1"/>
-          </p:cNvPicPr>
-          <p:nvPr/>
-        </p:nvPicPr>
-        <p:blipFill>
-          <a:blip r:embed="rId2"/>
-          <a:stretch>
-            <a:fillRect/>
-          </a:stretch>
-        </p:blipFill>
-        <p:spPr>
-          <a:xfrm>
-            <a:off x="0" y="0"/>
-            <a:ext cx="12192000" cy="6858000"/>
-          </a:xfrm>
-          <a:prstGeom prst="rect">
-            <a:avLst/>
-          </a:prstGeom>
-        </p:spPr>
-      </p:pic>
-    </p:spTree>
-  </p:cSld>
-  <p:clrMapOvr>
-    <a:masterClrMapping/>
-  </p:clrMapOvr>
-</p:sld>
-</file>
-
 <file path=ppt/slides/slide15.xml><?xml version="1.0" encoding="utf-8"?>
 <p:sld xmlns:a="http://schemas.openxmlformats.org/drawingml/2006/main" xmlns:p="http://schemas.openxmlformats.org/presentationml/2006/main" xmlns:r="http://schemas.openxmlformats.org/officeDocument/2006/relationships">
   <p:cSld>
@@ -5324,7 +5821,7 @@
       <p:grpSpPr/>
       <p:pic>
         <p:nvPicPr>
-          <p:cNvPr id="2" name="qual-scorecard" descr="qual-scorecard.png"/>
+          <p:cNvPr id="2" name="sec-results" descr="sec-results.png"/>
           <p:cNvPicPr>
             <a:picLocks noChangeAspect="1"/>
           </p:cNvPicPr>
@@ -5408,6 +5905,48 @@
       <p:grpSpPr/>
       <p:pic>
         <p:nvPicPr>
+          <p:cNvPr id="2" name="results-reads" descr="results-reads.png"/>
+          <p:cNvPicPr>
+            <a:picLocks noChangeAspect="1"/>
+          </p:cNvPicPr>
+          <p:nvPr/>
+        </p:nvPicPr>
+        <p:blipFill>
+          <a:blip r:embed="rId2"/>
+          <a:stretch>
+            <a:fillRect/>
+          </a:stretch>
+        </p:blipFill>
+        <p:spPr>
+          <a:xfrm>
+            <a:off x="0" y="0"/>
+            <a:ext cx="12192000" cy="6858000"/>
+          </a:xfrm>
+          <a:prstGeom prst="rect">
+            <a:avLst/>
+          </a:prstGeom>
+        </p:spPr>
+      </p:pic>
+    </p:spTree>
+  </p:cSld>
+  <p:clrMapOvr>
+    <a:masterClrMapping/>
+  </p:clrMapOvr>
+</p:sld>
+</file>
+
+<file path=ppt/slides/slide18.xml><?xml version="1.0" encoding="utf-8"?>
+<p:sld xmlns:a="http://schemas.openxmlformats.org/drawingml/2006/main" xmlns:p="http://schemas.openxmlformats.org/presentationml/2006/main" xmlns:r="http://schemas.openxmlformats.org/officeDocument/2006/relationships">
+  <p:cSld>
+    <p:spTree>
+      <p:nvGrpSpPr>
+        <p:cNvPr id="1" name=""/>
+        <p:cNvGrpSpPr/>
+        <p:nvPr/>
+      </p:nvGrpSpPr>
+      <p:grpSpPr/>
+      <p:pic>
+        <p:nvPicPr>
           <p:cNvPr id="2" name="qual-case" descr="qual-case.png"/>
           <p:cNvPicPr>
             <a:picLocks noChangeAspect="1"/>
@@ -5438,7 +5977,91 @@
 </p:sld>
 </file>
 
-<file path=ppt/slides/slide18.xml><?xml version="1.0" encoding="utf-8"?>
+<file path=ppt/slides/slide19.xml><?xml version="1.0" encoding="utf-8"?>
+<p:sld xmlns:a="http://schemas.openxmlformats.org/drawingml/2006/main" xmlns:p="http://schemas.openxmlformats.org/presentationml/2006/main" xmlns:r="http://schemas.openxmlformats.org/officeDocument/2006/relationships">
+  <p:cSld>
+    <p:spTree>
+      <p:nvGrpSpPr>
+        <p:cNvPr id="1" name=""/>
+        <p:cNvGrpSpPr/>
+        <p:nvPr/>
+      </p:nvGrpSpPr>
+      <p:grpSpPr/>
+      <p:pic>
+        <p:nvPicPr>
+          <p:cNvPr id="2" name="results-db" descr="results-db.png"/>
+          <p:cNvPicPr>
+            <a:picLocks noChangeAspect="1"/>
+          </p:cNvPicPr>
+          <p:nvPr/>
+        </p:nvPicPr>
+        <p:blipFill>
+          <a:blip r:embed="rId2"/>
+          <a:stretch>
+            <a:fillRect/>
+          </a:stretch>
+        </p:blipFill>
+        <p:spPr>
+          <a:xfrm>
+            <a:off x="0" y="0"/>
+            <a:ext cx="12192000" cy="6858000"/>
+          </a:xfrm>
+          <a:prstGeom prst="rect">
+            <a:avLst/>
+          </a:prstGeom>
+        </p:spPr>
+      </p:pic>
+    </p:spTree>
+  </p:cSld>
+  <p:clrMapOvr>
+    <a:masterClrMapping/>
+  </p:clrMapOvr>
+</p:sld>
+</file>
+
+<file path=ppt/slides/slide2.xml><?xml version="1.0" encoding="utf-8"?>
+<p:sld xmlns:a="http://schemas.openxmlformats.org/drawingml/2006/main" xmlns:p="http://schemas.openxmlformats.org/presentationml/2006/main" xmlns:r="http://schemas.openxmlformats.org/officeDocument/2006/relationships">
+  <p:cSld>
+    <p:spTree>
+      <p:nvGrpSpPr>
+        <p:cNvPr id="1" name=""/>
+        <p:cNvGrpSpPr/>
+        <p:nvPr/>
+      </p:nvGrpSpPr>
+      <p:grpSpPr/>
+      <p:pic>
+        <p:nvPicPr>
+          <p:cNvPr id="2" name="sec-motivation" descr="sec-motivation.png"/>
+          <p:cNvPicPr>
+            <a:picLocks noChangeAspect="1"/>
+          </p:cNvPicPr>
+          <p:nvPr/>
+        </p:nvPicPr>
+        <p:blipFill>
+          <a:blip r:embed="rId2"/>
+          <a:stretch>
+            <a:fillRect/>
+          </a:stretch>
+        </p:blipFill>
+        <p:spPr>
+          <a:xfrm>
+            <a:off x="0" y="0"/>
+            <a:ext cx="12192000" cy="6858000"/>
+          </a:xfrm>
+          <a:prstGeom prst="rect">
+            <a:avLst/>
+          </a:prstGeom>
+        </p:spPr>
+      </p:pic>
+    </p:spTree>
+  </p:cSld>
+  <p:clrMapOvr>
+    <a:masterClrMapping/>
+  </p:clrMapOvr>
+</p:sld>
+</file>
+
+<file path=ppt/slides/slide20.xml><?xml version="1.0" encoding="utf-8"?>
 <p:sld xmlns:a="http://schemas.openxmlformats.org/drawingml/2006/main" xmlns:p="http://schemas.openxmlformats.org/presentationml/2006/main" xmlns:r="http://schemas.openxmlformats.org/officeDocument/2006/relationships">
   <p:cSld>
     <p:spTree>
@@ -5480,7 +6103,217 @@
 </p:sld>
 </file>
 
-<file path=ppt/slides/slide19.xml><?xml version="1.0" encoding="utf-8"?>
+<file path=ppt/slides/slide21.xml><?xml version="1.0" encoding="utf-8"?>
+<p:sld xmlns:a="http://schemas.openxmlformats.org/drawingml/2006/main" xmlns:p="http://schemas.openxmlformats.org/presentationml/2006/main" xmlns:r="http://schemas.openxmlformats.org/officeDocument/2006/relationships">
+  <p:cSld>
+    <p:spTree>
+      <p:nvGrpSpPr>
+        <p:cNvPr id="1" name=""/>
+        <p:cNvGrpSpPr/>
+        <p:nvPr/>
+      </p:nvGrpSpPr>
+      <p:grpSpPr/>
+      <p:pic>
+        <p:nvPicPr>
+          <p:cNvPr id="2" name="results-policy" descr="results-policy.png"/>
+          <p:cNvPicPr>
+            <a:picLocks noChangeAspect="1"/>
+          </p:cNvPicPr>
+          <p:nvPr/>
+        </p:nvPicPr>
+        <p:blipFill>
+          <a:blip r:embed="rId2"/>
+          <a:stretch>
+            <a:fillRect/>
+          </a:stretch>
+        </p:blipFill>
+        <p:spPr>
+          <a:xfrm>
+            <a:off x="0" y="0"/>
+            <a:ext cx="12192000" cy="6858000"/>
+          </a:xfrm>
+          <a:prstGeom prst="rect">
+            <a:avLst/>
+          </a:prstGeom>
+        </p:spPr>
+      </p:pic>
+    </p:spTree>
+  </p:cSld>
+  <p:clrMapOvr>
+    <a:masterClrMapping/>
+  </p:clrMapOvr>
+</p:sld>
+</file>
+
+<file path=ppt/slides/slide22.xml><?xml version="1.0" encoding="utf-8"?>
+<p:sld xmlns:a="http://schemas.openxmlformats.org/drawingml/2006/main" xmlns:p="http://schemas.openxmlformats.org/presentationml/2006/main" xmlns:r="http://schemas.openxmlformats.org/officeDocument/2006/relationships">
+  <p:cSld>
+    <p:spTree>
+      <p:nvGrpSpPr>
+        <p:cNvPr id="1" name=""/>
+        <p:cNvGrpSpPr/>
+        <p:nvPr/>
+      </p:nvGrpSpPr>
+      <p:grpSpPr/>
+      <p:pic>
+        <p:nvPicPr>
+          <p:cNvPr id="2" name="nine-models" descr="nine-models.png"/>
+          <p:cNvPicPr>
+            <a:picLocks noChangeAspect="1"/>
+          </p:cNvPicPr>
+          <p:nvPr/>
+        </p:nvPicPr>
+        <p:blipFill>
+          <a:blip r:embed="rId2"/>
+          <a:stretch>
+            <a:fillRect/>
+          </a:stretch>
+        </p:blipFill>
+        <p:spPr>
+          <a:xfrm>
+            <a:off x="0" y="0"/>
+            <a:ext cx="12192000" cy="6858000"/>
+          </a:xfrm>
+          <a:prstGeom prst="rect">
+            <a:avLst/>
+          </a:prstGeom>
+        </p:spPr>
+      </p:pic>
+    </p:spTree>
+  </p:cSld>
+  <p:clrMapOvr>
+    <a:masterClrMapping/>
+  </p:clrMapOvr>
+</p:sld>
+</file>
+
+<file path=ppt/slides/slide23.xml><?xml version="1.0" encoding="utf-8"?>
+<p:sld xmlns:a="http://schemas.openxmlformats.org/drawingml/2006/main" xmlns:p="http://schemas.openxmlformats.org/presentationml/2006/main" xmlns:r="http://schemas.openxmlformats.org/officeDocument/2006/relationships">
+  <p:cSld>
+    <p:spTree>
+      <p:nvGrpSpPr>
+        <p:cNvPr id="1" name=""/>
+        <p:cNvGrpSpPr/>
+        <p:nvPr/>
+      </p:nvGrpSpPr>
+      <p:grpSpPr/>
+      <p:pic>
+        <p:nvPicPr>
+          <p:cNvPr id="2" name="drops" descr="drops.png"/>
+          <p:cNvPicPr>
+            <a:picLocks noChangeAspect="1"/>
+          </p:cNvPicPr>
+          <p:nvPr/>
+        </p:nvPicPr>
+        <p:blipFill>
+          <a:blip r:embed="rId2"/>
+          <a:stretch>
+            <a:fillRect/>
+          </a:stretch>
+        </p:blipFill>
+        <p:spPr>
+          <a:xfrm>
+            <a:off x="0" y="0"/>
+            <a:ext cx="12192000" cy="6858000"/>
+          </a:xfrm>
+          <a:prstGeom prst="rect">
+            <a:avLst/>
+          </a:prstGeom>
+        </p:spPr>
+      </p:pic>
+    </p:spTree>
+  </p:cSld>
+  <p:clrMapOvr>
+    <a:masterClrMapping/>
+  </p:clrMapOvr>
+</p:sld>
+</file>
+
+<file path=ppt/slides/slide24.xml><?xml version="1.0" encoding="utf-8"?>
+<p:sld xmlns:a="http://schemas.openxmlformats.org/drawingml/2006/main" xmlns:p="http://schemas.openxmlformats.org/presentationml/2006/main" xmlns:r="http://schemas.openxmlformats.org/officeDocument/2006/relationships">
+  <p:cSld>
+    <p:spTree>
+      <p:nvGrpSpPr>
+        <p:cNvPr id="1" name=""/>
+        <p:cNvGrpSpPr/>
+        <p:nvPr/>
+      </p:nvGrpSpPr>
+      <p:grpSpPr/>
+      <p:pic>
+        <p:nvPicPr>
+          <p:cNvPr id="2" name="slope" descr="slope.png"/>
+          <p:cNvPicPr>
+            <a:picLocks noChangeAspect="1"/>
+          </p:cNvPicPr>
+          <p:nvPr/>
+        </p:nvPicPr>
+        <p:blipFill>
+          <a:blip r:embed="rId2"/>
+          <a:stretch>
+            <a:fillRect/>
+          </a:stretch>
+        </p:blipFill>
+        <p:spPr>
+          <a:xfrm>
+            <a:off x="0" y="0"/>
+            <a:ext cx="12192000" cy="6858000"/>
+          </a:xfrm>
+          <a:prstGeom prst="rect">
+            <a:avLst/>
+          </a:prstGeom>
+        </p:spPr>
+      </p:pic>
+    </p:spTree>
+  </p:cSld>
+  <p:clrMapOvr>
+    <a:masterClrMapping/>
+  </p:clrMapOvr>
+</p:sld>
+</file>
+
+<file path=ppt/slides/slide25.xml><?xml version="1.0" encoding="utf-8"?>
+<p:sld xmlns:a="http://schemas.openxmlformats.org/drawingml/2006/main" xmlns:p="http://schemas.openxmlformats.org/presentationml/2006/main" xmlns:r="http://schemas.openxmlformats.org/officeDocument/2006/relationships">
+  <p:cSld>
+    <p:spTree>
+      <p:nvGrpSpPr>
+        <p:cNvPr id="1" name=""/>
+        <p:cNvGrpSpPr/>
+        <p:nvPr/>
+      </p:nvGrpSpPr>
+      <p:grpSpPr/>
+      <p:pic>
+        <p:nvPicPr>
+          <p:cNvPr id="2" name="sec-discussion" descr="sec-discussion.png"/>
+          <p:cNvPicPr>
+            <a:picLocks noChangeAspect="1"/>
+          </p:cNvPicPr>
+          <p:nvPr/>
+        </p:nvPicPr>
+        <p:blipFill>
+          <a:blip r:embed="rId2"/>
+          <a:stretch>
+            <a:fillRect/>
+          </a:stretch>
+        </p:blipFill>
+        <p:spPr>
+          <a:xfrm>
+            <a:off x="0" y="0"/>
+            <a:ext cx="12192000" cy="6858000"/>
+          </a:xfrm>
+          <a:prstGeom prst="rect">
+            <a:avLst/>
+          </a:prstGeom>
+        </p:spPr>
+      </p:pic>
+    </p:spTree>
+  </p:cSld>
+  <p:clrMapOvr>
+    <a:masterClrMapping/>
+  </p:clrMapOvr>
+</p:sld>
+</file>
+
+<file path=ppt/slides/slide26.xml><?xml version="1.0" encoding="utf-8"?>
 <p:sld xmlns:a="http://schemas.openxmlformats.org/drawingml/2006/main" xmlns:p="http://schemas.openxmlformats.org/presentationml/2006/main" xmlns:r="http://schemas.openxmlformats.org/officeDocument/2006/relationships">
   <p:cSld>
     <p:spTree>
@@ -5522,7 +6355,217 @@
 </p:sld>
 </file>
 
-<file path=ppt/slides/slide2.xml><?xml version="1.0" encoding="utf-8"?>
+<file path=ppt/slides/slide27.xml><?xml version="1.0" encoding="utf-8"?>
+<p:sld xmlns:a="http://schemas.openxmlformats.org/drawingml/2006/main" xmlns:p="http://schemas.openxmlformats.org/presentationml/2006/main" xmlns:r="http://schemas.openxmlformats.org/officeDocument/2006/relationships">
+  <p:cSld>
+    <p:spTree>
+      <p:nvGrpSpPr>
+        <p:cNvPr id="1" name=""/>
+        <p:cNvGrpSpPr/>
+        <p:nvPr/>
+      </p:nvGrpSpPr>
+      <p:grpSpPr/>
+      <p:pic>
+        <p:nvPicPr>
+          <p:cNvPr id="2" name="doctor" descr="doctor.png"/>
+          <p:cNvPicPr>
+            <a:picLocks noChangeAspect="1"/>
+          </p:cNvPicPr>
+          <p:nvPr/>
+        </p:nvPicPr>
+        <p:blipFill>
+          <a:blip r:embed="rId2"/>
+          <a:stretch>
+            <a:fillRect/>
+          </a:stretch>
+        </p:blipFill>
+        <p:spPr>
+          <a:xfrm>
+            <a:off x="0" y="0"/>
+            <a:ext cx="12192000" cy="6858000"/>
+          </a:xfrm>
+          <a:prstGeom prst="rect">
+            <a:avLst/>
+          </a:prstGeom>
+        </p:spPr>
+      </p:pic>
+    </p:spTree>
+  </p:cSld>
+  <p:clrMapOvr>
+    <a:masterClrMapping/>
+  </p:clrMapOvr>
+</p:sld>
+</file>
+
+<file path=ppt/slides/slide28.xml><?xml version="1.0" encoding="utf-8"?>
+<p:sld xmlns:a="http://schemas.openxmlformats.org/drawingml/2006/main" xmlns:p="http://schemas.openxmlformats.org/presentationml/2006/main" xmlns:r="http://schemas.openxmlformats.org/officeDocument/2006/relationships">
+  <p:cSld>
+    <p:spTree>
+      <p:nvGrpSpPr>
+        <p:cNvPr id="1" name=""/>
+        <p:cNvGrpSpPr/>
+        <p:nvPr/>
+      </p:nvGrpSpPr>
+      <p:grpSpPr/>
+      <p:pic>
+        <p:nvPicPr>
+          <p:cNvPr id="2" name="doctor-ui" descr="doctor-ui.png"/>
+          <p:cNvPicPr>
+            <a:picLocks noChangeAspect="1"/>
+          </p:cNvPicPr>
+          <p:nvPr/>
+        </p:nvPicPr>
+        <p:blipFill>
+          <a:blip r:embed="rId2"/>
+          <a:stretch>
+            <a:fillRect/>
+          </a:stretch>
+        </p:blipFill>
+        <p:spPr>
+          <a:xfrm>
+            <a:off x="0" y="0"/>
+            <a:ext cx="12192000" cy="6858000"/>
+          </a:xfrm>
+          <a:prstGeom prst="rect">
+            <a:avLst/>
+          </a:prstGeom>
+        </p:spPr>
+      </p:pic>
+    </p:spTree>
+  </p:cSld>
+  <p:clrMapOvr>
+    <a:masterClrMapping/>
+  </p:clrMapOvr>
+</p:sld>
+</file>
+
+<file path=ppt/slides/slide29.xml><?xml version="1.0" encoding="utf-8"?>
+<p:sld xmlns:a="http://schemas.openxmlformats.org/drawingml/2006/main" xmlns:p="http://schemas.openxmlformats.org/presentationml/2006/main" xmlns:r="http://schemas.openxmlformats.org/officeDocument/2006/relationships">
+  <p:cSld>
+    <p:spTree>
+      <p:nvGrpSpPr>
+        <p:cNvPr id="1" name=""/>
+        <p:cNvGrpSpPr/>
+        <p:nvPr/>
+      </p:nvGrpSpPr>
+      <p:grpSpPr/>
+      <p:pic>
+        <p:nvPicPr>
+          <p:cNvPr id="2" name="limits" descr="limits.png"/>
+          <p:cNvPicPr>
+            <a:picLocks noChangeAspect="1"/>
+          </p:cNvPicPr>
+          <p:nvPr/>
+        </p:nvPicPr>
+        <p:blipFill>
+          <a:blip r:embed="rId2"/>
+          <a:stretch>
+            <a:fillRect/>
+          </a:stretch>
+        </p:blipFill>
+        <p:spPr>
+          <a:xfrm>
+            <a:off x="0" y="0"/>
+            <a:ext cx="12192000" cy="6858000"/>
+          </a:xfrm>
+          <a:prstGeom prst="rect">
+            <a:avLst/>
+          </a:prstGeom>
+        </p:spPr>
+      </p:pic>
+    </p:spTree>
+  </p:cSld>
+  <p:clrMapOvr>
+    <a:masterClrMapping/>
+  </p:clrMapOvr>
+</p:sld>
+</file>
+
+<file path=ppt/slides/slide3.xml><?xml version="1.0" encoding="utf-8"?>
+<p:sld xmlns:a="http://schemas.openxmlformats.org/drawingml/2006/main" xmlns:p="http://schemas.openxmlformats.org/presentationml/2006/main" xmlns:r="http://schemas.openxmlformats.org/officeDocument/2006/relationships">
+  <p:cSld>
+    <p:spTree>
+      <p:nvGrpSpPr>
+        <p:cNvPr id="1" name=""/>
+        <p:cNvGrpSpPr/>
+        <p:nvPr/>
+      </p:nvGrpSpPr>
+      <p:grpSpPr/>
+      <p:pic>
+        <p:nvPicPr>
+          <p:cNvPr id="2" name="motivation" descr="motivation.png"/>
+          <p:cNvPicPr>
+            <a:picLocks noChangeAspect="1"/>
+          </p:cNvPicPr>
+          <p:nvPr/>
+        </p:nvPicPr>
+        <p:blipFill>
+          <a:blip r:embed="rId2"/>
+          <a:stretch>
+            <a:fillRect/>
+          </a:stretch>
+        </p:blipFill>
+        <p:spPr>
+          <a:xfrm>
+            <a:off x="0" y="0"/>
+            <a:ext cx="12192000" cy="6858000"/>
+          </a:xfrm>
+          <a:prstGeom prst="rect">
+            <a:avLst/>
+          </a:prstGeom>
+        </p:spPr>
+      </p:pic>
+    </p:spTree>
+  </p:cSld>
+  <p:clrMapOvr>
+    <a:masterClrMapping/>
+  </p:clrMapOvr>
+</p:sld>
+</file>
+
+<file path=ppt/slides/slide30.xml><?xml version="1.0" encoding="utf-8"?>
+<p:sld xmlns:a="http://schemas.openxmlformats.org/drawingml/2006/main" xmlns:p="http://schemas.openxmlformats.org/presentationml/2006/main" xmlns:r="http://schemas.openxmlformats.org/officeDocument/2006/relationships">
+  <p:cSld>
+    <p:spTree>
+      <p:nvGrpSpPr>
+        <p:cNvPr id="1" name=""/>
+        <p:cNvGrpSpPr/>
+        <p:nvPr/>
+      </p:nvGrpSpPr>
+      <p:grpSpPr/>
+      <p:pic>
+        <p:nvPicPr>
+          <p:cNvPr id="2" name="takeaways" descr="takeaways.png"/>
+          <p:cNvPicPr>
+            <a:picLocks noChangeAspect="1"/>
+          </p:cNvPicPr>
+          <p:nvPr/>
+        </p:nvPicPr>
+        <p:blipFill>
+          <a:blip r:embed="rId2"/>
+          <a:stretch>
+            <a:fillRect/>
+          </a:stretch>
+        </p:blipFill>
+        <p:spPr>
+          <a:xfrm>
+            <a:off x="0" y="0"/>
+            <a:ext cx="12192000" cy="6858000"/>
+          </a:xfrm>
+          <a:prstGeom prst="rect">
+            <a:avLst/>
+          </a:prstGeom>
+        </p:spPr>
+      </p:pic>
+    </p:spTree>
+  </p:cSld>
+  <p:clrMapOvr>
+    <a:masterClrMapping/>
+  </p:clrMapOvr>
+</p:sld>
+</file>
+
+<file path=ppt/slides/slide4.xml><?xml version="1.0" encoding="utf-8"?>
 <p:sld xmlns:a="http://schemas.openxmlformats.org/drawingml/2006/main" xmlns:p="http://schemas.openxmlformats.org/presentationml/2006/main" xmlns:r="http://schemas.openxmlformats.org/officeDocument/2006/relationships">
   <p:cSld>
     <p:spTree>
@@ -5564,175 +6607,7 @@
 </p:sld>
 </file>
 
-<file path=ppt/slides/slide20.xml><?xml version="1.0" encoding="utf-8"?>
-<p:sld xmlns:a="http://schemas.openxmlformats.org/drawingml/2006/main" xmlns:p="http://schemas.openxmlformats.org/presentationml/2006/main" xmlns:r="http://schemas.openxmlformats.org/officeDocument/2006/relationships">
-  <p:cSld>
-    <p:spTree>
-      <p:nvGrpSpPr>
-        <p:cNvPr id="1" name=""/>
-        <p:cNvGrpSpPr/>
-        <p:nvPr/>
-      </p:nvGrpSpPr>
-      <p:grpSpPr/>
-      <p:pic>
-        <p:nvPicPr>
-          <p:cNvPr id="2" name="doctor" descr="doctor.png"/>
-          <p:cNvPicPr>
-            <a:picLocks noChangeAspect="1"/>
-          </p:cNvPicPr>
-          <p:nvPr/>
-        </p:nvPicPr>
-        <p:blipFill>
-          <a:blip r:embed="rId2"/>
-          <a:stretch>
-            <a:fillRect/>
-          </a:stretch>
-        </p:blipFill>
-        <p:spPr>
-          <a:xfrm>
-            <a:off x="0" y="0"/>
-            <a:ext cx="12192000" cy="6858000"/>
-          </a:xfrm>
-          <a:prstGeom prst="rect">
-            <a:avLst/>
-          </a:prstGeom>
-        </p:spPr>
-      </p:pic>
-    </p:spTree>
-  </p:cSld>
-  <p:clrMapOvr>
-    <a:masterClrMapping/>
-  </p:clrMapOvr>
-</p:sld>
-</file>
-
-<file path=ppt/slides/slide21.xml><?xml version="1.0" encoding="utf-8"?>
-<p:sld xmlns:a="http://schemas.openxmlformats.org/drawingml/2006/main" xmlns:p="http://schemas.openxmlformats.org/presentationml/2006/main" xmlns:r="http://schemas.openxmlformats.org/officeDocument/2006/relationships">
-  <p:cSld>
-    <p:spTree>
-      <p:nvGrpSpPr>
-        <p:cNvPr id="1" name=""/>
-        <p:cNvGrpSpPr/>
-        <p:nvPr/>
-      </p:nvGrpSpPr>
-      <p:grpSpPr/>
-      <p:pic>
-        <p:nvPicPr>
-          <p:cNvPr id="2" name="doctor-ui" descr="doctor-ui.png"/>
-          <p:cNvPicPr>
-            <a:picLocks noChangeAspect="1"/>
-          </p:cNvPicPr>
-          <p:nvPr/>
-        </p:nvPicPr>
-        <p:blipFill>
-          <a:blip r:embed="rId2"/>
-          <a:stretch>
-            <a:fillRect/>
-          </a:stretch>
-        </p:blipFill>
-        <p:spPr>
-          <a:xfrm>
-            <a:off x="0" y="0"/>
-            <a:ext cx="12192000" cy="6858000"/>
-          </a:xfrm>
-          <a:prstGeom prst="rect">
-            <a:avLst/>
-          </a:prstGeom>
-        </p:spPr>
-      </p:pic>
-    </p:spTree>
-  </p:cSld>
-  <p:clrMapOvr>
-    <a:masterClrMapping/>
-  </p:clrMapOvr>
-</p:sld>
-</file>
-
-<file path=ppt/slides/slide22.xml><?xml version="1.0" encoding="utf-8"?>
-<p:sld xmlns:a="http://schemas.openxmlformats.org/drawingml/2006/main" xmlns:p="http://schemas.openxmlformats.org/presentationml/2006/main" xmlns:r="http://schemas.openxmlformats.org/officeDocument/2006/relationships">
-  <p:cSld>
-    <p:spTree>
-      <p:nvGrpSpPr>
-        <p:cNvPr id="1" name=""/>
-        <p:cNvGrpSpPr/>
-        <p:nvPr/>
-      </p:nvGrpSpPr>
-      <p:grpSpPr/>
-      <p:pic>
-        <p:nvPicPr>
-          <p:cNvPr id="2" name="limits" descr="limits.png"/>
-          <p:cNvPicPr>
-            <a:picLocks noChangeAspect="1"/>
-          </p:cNvPicPr>
-          <p:nvPr/>
-        </p:nvPicPr>
-        <p:blipFill>
-          <a:blip r:embed="rId2"/>
-          <a:stretch>
-            <a:fillRect/>
-          </a:stretch>
-        </p:blipFill>
-        <p:spPr>
-          <a:xfrm>
-            <a:off x="0" y="0"/>
-            <a:ext cx="12192000" cy="6858000"/>
-          </a:xfrm>
-          <a:prstGeom prst="rect">
-            <a:avLst/>
-          </a:prstGeom>
-        </p:spPr>
-      </p:pic>
-    </p:spTree>
-  </p:cSld>
-  <p:clrMapOvr>
-    <a:masterClrMapping/>
-  </p:clrMapOvr>
-</p:sld>
-</file>
-
-<file path=ppt/slides/slide23.xml><?xml version="1.0" encoding="utf-8"?>
-<p:sld xmlns:a="http://schemas.openxmlformats.org/drawingml/2006/main" xmlns:p="http://schemas.openxmlformats.org/presentationml/2006/main" xmlns:r="http://schemas.openxmlformats.org/officeDocument/2006/relationships">
-  <p:cSld>
-    <p:spTree>
-      <p:nvGrpSpPr>
-        <p:cNvPr id="1" name=""/>
-        <p:cNvGrpSpPr/>
-        <p:nvPr/>
-      </p:nvGrpSpPr>
-      <p:grpSpPr/>
-      <p:pic>
-        <p:nvPicPr>
-          <p:cNvPr id="2" name="takeaways" descr="takeaways.png"/>
-          <p:cNvPicPr>
-            <a:picLocks noChangeAspect="1"/>
-          </p:cNvPicPr>
-          <p:nvPr/>
-        </p:nvPicPr>
-        <p:blipFill>
-          <a:blip r:embed="rId2"/>
-          <a:stretch>
-            <a:fillRect/>
-          </a:stretch>
-        </p:blipFill>
-        <p:spPr>
-          <a:xfrm>
-            <a:off x="0" y="0"/>
-            <a:ext cx="12192000" cy="6858000"/>
-          </a:xfrm>
-          <a:prstGeom prst="rect">
-            <a:avLst/>
-          </a:prstGeom>
-        </p:spPr>
-      </p:pic>
-    </p:spTree>
-  </p:cSld>
-  <p:clrMapOvr>
-    <a:masterClrMapping/>
-  </p:clrMapOvr>
-</p:sld>
-</file>
-
-<file path=ppt/slides/slide3.xml><?xml version="1.0" encoding="utf-8"?>
+<file path=ppt/slides/slide5.xml><?xml version="1.0" encoding="utf-8"?>
 <p:sld xmlns:a="http://schemas.openxmlformats.org/drawingml/2006/main" xmlns:p="http://schemas.openxmlformats.org/presentationml/2006/main" xmlns:r="http://schemas.openxmlformats.org/officeDocument/2006/relationships">
   <p:cSld>
     <p:spTree>
@@ -5774,7 +6649,49 @@
 </p:sld>
 </file>
 
-<file path=ppt/slides/slide4.xml><?xml version="1.0" encoding="utf-8"?>
+<file path=ppt/slides/slide6.xml><?xml version="1.0" encoding="utf-8"?>
+<p:sld xmlns:a="http://schemas.openxmlformats.org/drawingml/2006/main" xmlns:p="http://schemas.openxmlformats.org/presentationml/2006/main" xmlns:r="http://schemas.openxmlformats.org/officeDocument/2006/relationships">
+  <p:cSld>
+    <p:spTree>
+      <p:nvGrpSpPr>
+        <p:cNvPr id="1" name=""/>
+        <p:cNvGrpSpPr/>
+        <p:nvPr/>
+      </p:nvGrpSpPr>
+      <p:grpSpPr/>
+      <p:pic>
+        <p:nvPicPr>
+          <p:cNvPr id="2" name="traces" descr="traces.png"/>
+          <p:cNvPicPr>
+            <a:picLocks noChangeAspect="1"/>
+          </p:cNvPicPr>
+          <p:nvPr/>
+        </p:nvPicPr>
+        <p:blipFill>
+          <a:blip r:embed="rId2"/>
+          <a:stretch>
+            <a:fillRect/>
+          </a:stretch>
+        </p:blipFill>
+        <p:spPr>
+          <a:xfrm>
+            <a:off x="0" y="0"/>
+            <a:ext cx="12192000" cy="6858000"/>
+          </a:xfrm>
+          <a:prstGeom prst="rect">
+            <a:avLst/>
+          </a:prstGeom>
+        </p:spPr>
+      </p:pic>
+    </p:spTree>
+  </p:cSld>
+  <p:clrMapOvr>
+    <a:masterClrMapping/>
+  </p:clrMapOvr>
+</p:sld>
+</file>
+
+<file path=ppt/slides/slide7.xml><?xml version="1.0" encoding="utf-8"?>
 <p:sld xmlns:a="http://schemas.openxmlformats.org/drawingml/2006/main" xmlns:p="http://schemas.openxmlformats.org/presentationml/2006/main" xmlns:r="http://schemas.openxmlformats.org/officeDocument/2006/relationships">
   <p:cSld>
     <p:spTree>
@@ -5816,7 +6733,7 @@
 </p:sld>
 </file>
 
-<file path=ppt/slides/slide5.xml><?xml version="1.0" encoding="utf-8"?>
+<file path=ppt/slides/slide8.xml><?xml version="1.0" encoding="utf-8"?>
 <p:sld xmlns:a="http://schemas.openxmlformats.org/drawingml/2006/main" xmlns:p="http://schemas.openxmlformats.org/presentationml/2006/main" xmlns:r="http://schemas.openxmlformats.org/officeDocument/2006/relationships">
   <p:cSld>
     <p:spTree>
@@ -5828,7 +6745,7 @@
       <p:grpSpPr/>
       <p:pic>
         <p:nvPicPr>
-          <p:cNvPr id="2" name="traces" descr="traces.png"/>
+          <p:cNvPr id="2" name="sec-methodology" descr="sec-methodology.png"/>
           <p:cNvPicPr>
             <a:picLocks noChangeAspect="1"/>
           </p:cNvPicPr>
@@ -5858,7 +6775,7 @@
 </p:sld>
 </file>
 
-<file path=ppt/slides/slide6.xml><?xml version="1.0" encoding="utf-8"?>
+<file path=ppt/slides/slide9.xml><?xml version="1.0" encoding="utf-8"?>
 <p:sld xmlns:a="http://schemas.openxmlformats.org/drawingml/2006/main" xmlns:p="http://schemas.openxmlformats.org/presentationml/2006/main" xmlns:r="http://schemas.openxmlformats.org/officeDocument/2006/relationships">
   <p:cSld>
     <p:spTree>
@@ -5871,132 +6788,6 @@
       <p:pic>
         <p:nvPicPr>
           <p:cNvPr id="2" name="definition" descr="definition.png"/>
-          <p:cNvPicPr>
-            <a:picLocks noChangeAspect="1"/>
-          </p:cNvPicPr>
-          <p:nvPr/>
-        </p:nvPicPr>
-        <p:blipFill>
-          <a:blip r:embed="rId2"/>
-          <a:stretch>
-            <a:fillRect/>
-          </a:stretch>
-        </p:blipFill>
-        <p:spPr>
-          <a:xfrm>
-            <a:off x="0" y="0"/>
-            <a:ext cx="12192000" cy="6858000"/>
-          </a:xfrm>
-          <a:prstGeom prst="rect">
-            <a:avLst/>
-          </a:prstGeom>
-        </p:spPr>
-      </p:pic>
-    </p:spTree>
-  </p:cSld>
-  <p:clrMapOvr>
-    <a:masterClrMapping/>
-  </p:clrMapOvr>
-</p:sld>
-</file>
-
-<file path=ppt/slides/slide7.xml><?xml version="1.0" encoding="utf-8"?>
-<p:sld xmlns:a="http://schemas.openxmlformats.org/drawingml/2006/main" xmlns:p="http://schemas.openxmlformats.org/presentationml/2006/main" xmlns:r="http://schemas.openxmlformats.org/officeDocument/2006/relationships">
-  <p:cSld>
-    <p:spTree>
-      <p:nvGrpSpPr>
-        <p:cNvPr id="1" name=""/>
-        <p:cNvGrpSpPr/>
-        <p:nvPr/>
-      </p:nvGrpSpPr>
-      <p:grpSpPr/>
-      <p:pic>
-        <p:nvPicPr>
-          <p:cNvPr id="2" name="read-gate" descr="read-gate.png"/>
-          <p:cNvPicPr>
-            <a:picLocks noChangeAspect="1"/>
-          </p:cNvPicPr>
-          <p:nvPr/>
-        </p:nvPicPr>
-        <p:blipFill>
-          <a:blip r:embed="rId2"/>
-          <a:stretch>
-            <a:fillRect/>
-          </a:stretch>
-        </p:blipFill>
-        <p:spPr>
-          <a:xfrm>
-            <a:off x="0" y="0"/>
-            <a:ext cx="12192000" cy="6858000"/>
-          </a:xfrm>
-          <a:prstGeom prst="rect">
-            <a:avLst/>
-          </a:prstGeom>
-        </p:spPr>
-      </p:pic>
-    </p:spTree>
-  </p:cSld>
-  <p:clrMapOvr>
-    <a:masterClrMapping/>
-  </p:clrMapOvr>
-</p:sld>
-</file>
-
-<file path=ppt/slides/slide8.xml><?xml version="1.0" encoding="utf-8"?>
-<p:sld xmlns:a="http://schemas.openxmlformats.org/drawingml/2006/main" xmlns:p="http://schemas.openxmlformats.org/presentationml/2006/main" xmlns:r="http://schemas.openxmlformats.org/officeDocument/2006/relationships">
-  <p:cSld>
-    <p:spTree>
-      <p:nvGrpSpPr>
-        <p:cNvPr id="1" name=""/>
-        <p:cNvGrpSpPr/>
-        <p:nvPr/>
-      </p:nvGrpSpPr>
-      <p:grpSpPr/>
-      <p:pic>
-        <p:nvPicPr>
-          <p:cNvPr id="2" name="twins" descr="twins.png"/>
-          <p:cNvPicPr>
-            <a:picLocks noChangeAspect="1"/>
-          </p:cNvPicPr>
-          <p:nvPr/>
-        </p:nvPicPr>
-        <p:blipFill>
-          <a:blip r:embed="rId2"/>
-          <a:stretch>
-            <a:fillRect/>
-          </a:stretch>
-        </p:blipFill>
-        <p:spPr>
-          <a:xfrm>
-            <a:off x="0" y="0"/>
-            <a:ext cx="12192000" cy="6858000"/>
-          </a:xfrm>
-          <a:prstGeom prst="rect">
-            <a:avLst/>
-          </a:prstGeom>
-        </p:spPr>
-      </p:pic>
-    </p:spTree>
-  </p:cSld>
-  <p:clrMapOvr>
-    <a:masterClrMapping/>
-  </p:clrMapOvr>
-</p:sld>
-</file>
-
-<file path=ppt/slides/slide9.xml><?xml version="1.0" encoding="utf-8"?>
-<p:sld xmlns:a="http://schemas.openxmlformats.org/drawingml/2006/main" xmlns:p="http://schemas.openxmlformats.org/presentationml/2006/main" xmlns:r="http://schemas.openxmlformats.org/officeDocument/2006/relationships">
-  <p:cSld>
-    <p:spTree>
-      <p:nvGrpSpPr>
-        <p:cNvPr id="1" name=""/>
-        <p:cNvGrpSpPr/>
-        <p:nvPr/>
-      </p:nvGrpSpPr>
-      <p:grpSpPr/>
-      <p:pic>
-        <p:nvPicPr>
-          <p:cNvPr id="2" name="gate-reads" descr="gate-reads.png"/>
           <p:cNvPicPr>
             <a:picLocks noChangeAspect="1"/>
           </p:cNvPicPr>

</xml_diff>

<commit_message>
Simplify the gate implementation slides; move their limits to discussion
Co-Authored-By: Claude Opus 5.5 (1M context) <noreply@anthropic.com>
Claude-Session: https://claude.ai/code/session_01MtfJPedLYuXacbp8WXfd3s
</commit_message>
<xml_diff>
--- a/docs/drafts/2026-10-10-presentation-no-op-validity.pptx
+++ b/docs/drafts/2026-10-10-presentation-no-op-validity.pptx
@@ -741,7 +741,7 @@
           <a:lstStyle/>
           <a:p>
             <a:r>
-              <a:t>The gate is deterministic and needs no LLM judge. Pruning route-only reads matters: an agent can find a reservation ID in more than one way, and we do not want to fail an agent for the route it took. For the 7 tasks outside the gate there is no read that would reveal the answer, so a read requirement would test nothing.</a:t>
+              <a:t>Task IDs: 0, 1, 4, 9, 10, 26, 28, 31, 34, 36, 41, 43, 45, 47, 48, 49. Reads come from each task's gold actions; reads that only find an ID are dropped, and a read is matched on its identifying arguments.</a:t>
             </a:r>
           </a:p>
         </p:txBody>
@@ -811,7 +811,7 @@
           <a:lstStyle/>
           <a:p>
             <a:r>
-              <a:t>The policy-as-code oracle is what lets us search for the flip mechanically instead of guessing. Validation runs the real tau2 evaluator on scripted trajectories, and checks that the patch changes only the named records. Task 4 was dropped after a live run showed the user's goal could not be reached. Lenient scoring: a twin counts as passed when the right write happened, even if the episode failed for another reason.</a:t>
+              <a:t>Task IDs: 0, 1, 9, 26, 28, 41, 43, 45, 47, 48, 49. Fields flipped: business cabin (7), booked in the last 24 hours (3), insurance (1). The policy is written as code, a search finds the one-field edit, and each twin is checked with the real grader. Twins are scored leniently.</a:t>
             </a:r>
           </a:p>
         </p:txBody>
@@ -881,7 +881,7 @@
           <a:lstStyle/>
           <a:p>
             <a:r>
-              <a:t>Changing a policy sentence is the only way to make the right answer a write when the deciding fact is a rule, not data. The scripts for tasks 2, 5 and 27 have known faults (see the qualitative slides), so this gate is the weakest of the three. Lenient scoring applies here too.</a:t>
+              <a:t>Task IDs: 2, 5, 27, 38, all delayed-flight complaints. The right write on the twin is send_certificate: $50 on 2 and 38, $200 on 5, $150 on 27. Twins are scored leniently.</a:t>
             </a:r>
           </a:p>
         </p:txBody>

</xml_diff>

<commit_message>
Draft slides: drop hand-review boxes from results; add a removal-causes slide
Co-Authored-By: Claude Opus 5.5 (1M context) <noreply@anthropic.com>
Claude-Session: https://claude.ai/code/session_01MtfJPedLYuXacbp8WXfd3s
</commit_message>
<xml_diff>
--- a/docs/drafts/2026-10-10-presentation-no-op-validity.pptx
+++ b/docs/drafts/2026-10-10-presentation-no-op-validity.pptx
@@ -35,6 +35,7 @@
     <p:sldId id="283" r:id="rId35"/>
     <p:sldId id="284" r:id="rId36"/>
     <p:sldId id="285" r:id="rId37"/>
+    <p:sldId id="286" r:id="rId38"/>
   </p:sldIdLst>
   <p:sldSz cx="12192000" cy="6858000" type="screen4x3"/>
   <p:notesSz cx="6858000" cy="9144000"/>
@@ -1091,7 +1092,7 @@
           <a:lstStyle/>
           <a:p>
             <a:r>
-              <a:t>The read gate removes 16 of the null agent's 23 passes but only 0.7 to 2.3 points from the four models, which nearly always read before refusing. Reads are needed but not enough to separate the models. Hand review: every removal was an unreasoned pass, so the gate is precise.</a:t>
+              <a:t>The read gate removes 16 of the null agent's 23 passes but only 0.7 to 2.3 points from the four models, which nearly always read before refusing. Reads are needed but not enough to separate the models.</a:t>
             </a:r>
           </a:p>
         </p:txBody>
@@ -1161,7 +1162,7 @@
           <a:lstStyle/>
           <a:p>
             <a:r>
-              <a:t>This is a rule error that no read check can see: the read was made. Only the twin shows that the cabin fact does not drive haiku's decision. If we count these as true positives, the DB twin scores 6 right / 4 wrong cause / 7 false positive overall, and haiku's DB twin is 4/0/0. Decide which reading we present before the talk.</a:t>
+              <a:t>This is a rule error that no read check can see: the read was made. Only the twin shows that the cabin fact does not drive haiku's decision.</a:t>
             </a:r>
           </a:p>
         </p:txBody>
@@ -2001,7 +2002,7 @@
           <a:lstStyle/>
           <a:p>
             <a:r>
-              <a:t>Say these plainly. The reads gate result is solid. The DB twin result is solid on competent models, with known false positives from lost tool calls. The policy twin needs fixed scripts before any of its removals count as evidence.</a:t>
+              <a:t>The read gate is precise: every removal was an unreasoned pass. The twins also remove passes for reasons other than the agent's decision. Of the 9 DB-flip cases, 5 are maverick's (3 lost text calls on task 49, 2 rule errors) and 3 are haiku's business-cabin refusals. Most policy-flip cases come from the user scripts for tasks 2, 5 and 27. Fixes: detect text-form tool calls, fix the scripts, and add placebo twins to measure noise.</a:t>
             </a:r>
           </a:p>
         </p:txBody>
@@ -2097,6 +2098,76 @@
 </file>
 
 <file path=ppt/notesSlides/notesSlide30.xml><?xml version="1.0" encoding="utf-8"?>
+<p:notes xmlns:a="http://schemas.openxmlformats.org/drawingml/2006/main" xmlns:p="http://schemas.openxmlformats.org/presentationml/2006/main" xmlns:r="http://schemas.openxmlformats.org/officeDocument/2006/relationships">
+  <p:cSld>
+    <p:spTree>
+      <p:nvGrpSpPr>
+        <p:cNvPr id="1" name=""/>
+        <p:cNvGrpSpPr/>
+        <p:nvPr/>
+      </p:nvGrpSpPr>
+      <p:grpSpPr>
+        <a:xfrm>
+          <a:off x="0" y="0"/>
+          <a:ext cx="0" cy="0"/>
+          <a:chOff x="0" y="0"/>
+          <a:chExt cx="0" cy="0"/>
+        </a:xfrm>
+      </p:grpSpPr>
+      <p:sp>
+        <p:nvSpPr>
+          <p:cNvPr id="2" name="Slide Image Placeholder 1"/>
+          <p:cNvSpPr>
+            <a:spLocks noGrp="1"/>
+          </p:cNvSpPr>
+          <p:nvPr>
+            <p:ph type="sldImg" idx="2"/>
+          </p:nvPr>
+        </p:nvSpPr>
+        <p:spPr/>
+      </p:sp>
+      <p:sp>
+        <p:nvSpPr>
+          <p:cNvPr id="3" name="Notes Placeholder 2"/>
+          <p:cNvSpPr>
+            <a:spLocks noGrp="1"/>
+          </p:cNvSpPr>
+          <p:nvPr>
+            <p:ph type="body" idx="3" sz="quarter"/>
+          </p:nvPr>
+        </p:nvSpPr>
+        <p:spPr/>
+        <p:txBody>
+          <a:bodyPr/>
+          <a:lstStyle/>
+          <a:p>
+            <a:r>
+              <a:t>Say these plainly. The reads gate result is solid. The DB twin result is solid on competent models, but some removals come from lost tool calls. The policy twin needs fixed scripts before any of its removals count as evidence.</a:t>
+            </a:r>
+          </a:p>
+        </p:txBody>
+      </p:sp>
+      <p:sp>
+        <p:nvSpPr>
+          <p:cNvPr id="4" name="Slide Number Placeholder 3"/>
+          <p:cNvSpPr>
+            <a:spLocks noGrp="1"/>
+          </p:cNvSpPr>
+          <p:nvPr>
+            <p:ph type="sldNum" idx="5" sz="quarter"/>
+          </p:nvPr>
+        </p:nvSpPr>
+        <p:spPr/>
+      </p:sp>
+    </p:spTree>
+  </p:cSld>
+  <p:clrMapOvr>
+    <a:masterClrMapping/>
+  </p:clrMapOvr>
+</p:notes>
+</file>
+
+<file path=ppt/notesSlides/notesSlide31.xml><?xml version="1.0" encoding="utf-8"?>
 <p:notes xmlns:a="http://schemas.openxmlformats.org/drawingml/2006/main" xmlns:p="http://schemas.openxmlformats.org/presentationml/2006/main" xmlns:r="http://schemas.openxmlformats.org/officeDocument/2006/relationships">
   <p:cSld>
     <p:spTree>
@@ -6451,7 +6522,7 @@
       <p:grpSpPr/>
       <p:pic>
         <p:nvPicPr>
-          <p:cNvPr id="2" name="limits" descr="limits.png"/>
+          <p:cNvPr id="2" name="removal-causes" descr="removal-causes.png"/>
           <p:cNvPicPr>
             <a:picLocks noChangeAspect="1"/>
           </p:cNvPicPr>
@@ -6524,6 +6595,48 @@
 </file>
 
 <file path=ppt/slides/slide30.xml><?xml version="1.0" encoding="utf-8"?>
+<p:sld xmlns:a="http://schemas.openxmlformats.org/drawingml/2006/main" xmlns:p="http://schemas.openxmlformats.org/presentationml/2006/main" xmlns:r="http://schemas.openxmlformats.org/officeDocument/2006/relationships">
+  <p:cSld>
+    <p:spTree>
+      <p:nvGrpSpPr>
+        <p:cNvPr id="1" name=""/>
+        <p:cNvGrpSpPr/>
+        <p:nvPr/>
+      </p:nvGrpSpPr>
+      <p:grpSpPr/>
+      <p:pic>
+        <p:nvPicPr>
+          <p:cNvPr id="2" name="limits" descr="limits.png"/>
+          <p:cNvPicPr>
+            <a:picLocks noChangeAspect="1"/>
+          </p:cNvPicPr>
+          <p:nvPr/>
+        </p:nvPicPr>
+        <p:blipFill>
+          <a:blip r:embed="rId2"/>
+          <a:stretch>
+            <a:fillRect/>
+          </a:stretch>
+        </p:blipFill>
+        <p:spPr>
+          <a:xfrm>
+            <a:off x="0" y="0"/>
+            <a:ext cx="12192000" cy="6858000"/>
+          </a:xfrm>
+          <a:prstGeom prst="rect">
+            <a:avLst/>
+          </a:prstGeom>
+        </p:spPr>
+      </p:pic>
+    </p:spTree>
+  </p:cSld>
+  <p:clrMapOvr>
+    <a:masterClrMapping/>
+  </p:clrMapOvr>
+</p:sld>
+</file>
+
+<file path=ppt/slides/slide31.xml><?xml version="1.0" encoding="utf-8"?>
 <p:sld xmlns:a="http://schemas.openxmlformats.org/drawingml/2006/main" xmlns:p="http://schemas.openxmlformats.org/presentationml/2006/main" xmlns:r="http://schemas.openxmlformats.org/officeDocument/2006/relationships">
   <p:cSld>
     <p:spTree>

</xml_diff>

<commit_message>
Presentation: three sections, limitations slide, appendix
Co-Authored-By: Claude Opus 5.5 (1M context) <noreply@anthropic.com>
Claude-Session: https://claude.ai/code/session_01MtfJPedLYuXacbp8WXfd3s
</commit_message>
<xml_diff>
--- a/docs/drafts/2026-10-10-presentation-no-op-validity.pptx
+++ b/docs/drafts/2026-10-10-presentation-no-op-validity.pptx
@@ -36,6 +36,8 @@
     <p:sldId id="284" r:id="rId36"/>
     <p:sldId id="285" r:id="rId37"/>
     <p:sldId id="286" r:id="rId38"/>
+    <p:sldId id="287" r:id="rId39"/>
+    <p:sldId id="288" r:id="rId40"/>
   </p:sldIdLst>
   <p:sldSz cx="12192000" cy="6858000" type="screen4x3"/>
   <p:notesSz cx="6858000" cy="9144000"/>
@@ -1722,7 +1724,7 @@
           <a:lstStyle/>
           <a:p>
             <a:r>
-              <a:t>Section start.</a:t>
+              <a:t>Coverage: the read gate covers 16 tasks, the DB flip 11, the policy flip 4 (2, 5, 27, 38). Only 6, 13 and 46 have none. Of 16 DB-flip removals, 9 looked reasoned on the original; of 29 policy-flip removals, 13 did. Most of those come from maverick's text-form calls and the twin scripts for tasks 2, 5 and 27. Open case: haiku reads "business" on the task 47 twin and still refuses; it is unclear whether that is a real catch.</a:t>
             </a:r>
           </a:p>
         </p:txBody>
@@ -1792,7 +1794,7 @@
           <a:lstStyle/>
           <a:p>
             <a:r>
-              <a:t>An attempted write is a real call that failed or changed nothing, or a write typed as text and lost. Most are maverick's. The projection is of the headline score (reads plus all twins) and is not yet computed by the scoreboard. The null agent stays at 3. This revives something close to the formalization's "no forbidden writes" check, set aside on 2026-10-03, so it needs a decisions-log entry.</a:t>
+              <a:t>Null agent 23 of 50 originally, 7 under the read gate, 3 under reads plus all twins. luna goes 39.0 to 35.7. Thank you; questions.</a:t>
             </a:r>
           </a:p>
         </p:txBody>
@@ -1862,7 +1864,7 @@
           <a:lstStyle/>
           <a:p>
             <a:r>
-              <a:t>Step 1 is fully automatic and tells you whether steps 2 to 4 are needed at all. The airline numbers on the right are the checks this talk evaluated, packaged in the doctor. Minimum a benchmark must expose: a way to run an empty agent and a state-based grader. Twins need a settable initial state and the ability to score a hand-made trajectory. Policy flips need the policy as plain text in the agent's prompt. Every tau2 tool already carries a READ or WRITE label, so the doctor uses those instead of hand-written sets.</a:t>
+              <a:t>End of the talk. The appendix follows.</a:t>
             </a:r>
           </a:p>
         </p:txBody>
@@ -1932,7 +1934,7 @@
           <a:lstStyle/>
           <a:p>
             <a:r>
-              <a:t>In the screenshot, the top twin (reservation made within 24 hours) passes validation. The bottom one was edited by hand to a bad patch, and the grader's validation error shows right away. Every review records who approved what, and when.</a:t>
+              <a:t>Backup slides for questions.</a:t>
             </a:r>
           </a:p>
         </p:txBody>
@@ -2002,7 +2004,7 @@
           <a:lstStyle/>
           <a:p>
             <a:r>
-              <a:t>The read gate is precise: every removal was an unreasoned pass. The twins also remove passes for reasons other than the agent's decision. Of the 9 DB-flip cases, 5 are maverick's (3 lost text calls on task 49, 2 rule errors) and 3 are haiku's business-cabin refusals. Most policy-flip cases come from the user scripts for tasks 2, 5 and 27. Fixes: detect text-form tool calls, fix the scripts, and add placebo twins to measure noise.</a:t>
+              <a:t>An attempted write is a real call that failed or changed nothing, or a write typed as text and lost. Most are maverick's. The projection is of the headline score (reads plus all twins) and is not yet computed by the scoreboard. The null agent stays at 3. This revives something close to the formalization's "no forbidden writes" check, set aside on 2026-10-03, so it needs a decisions-log entry.</a:t>
             </a:r>
           </a:p>
         </p:txBody>
@@ -2142,7 +2144,7 @@
           <a:lstStyle/>
           <a:p>
             <a:r>
-              <a:t>Say these plainly. The reads gate result is solid. The DB twin result is solid on competent models, but some removals come from lost tool calls. The policy twin needs fixed scripts before any of its removals count as evidence.</a:t>
+              <a:t>The read gate is precise: every removal was an unreasoned pass. The twins also remove passes for reasons other than the agent's decision. Of the 9 DB-flip cases, 5 are maverick's (3 lost text calls on task 49, 2 rule errors) and 3 are haiku's business-cabin refusals. Most policy-flip cases come from the user scripts for tasks 2, 5 and 27. Fixes: detect text-form tool calls, fix the scripts, and add placebo twins to measure noise.</a:t>
             </a:r>
           </a:p>
         </p:txBody>
@@ -2212,7 +2214,147 @@
           <a:lstStyle/>
           <a:p>
             <a:r>
-              <a:t>Null agent 23 of 50 originally, 7 under the read gate, 3 under reads plus all twins. luna goes 39.0 to 35.7. Thank you; questions.</a:t>
+              <a:t>Say these plainly. The reads gate result is solid. The DB twin result is solid on competent models, but some removals come from lost tool calls. The policy twin needs fixed scripts before any of its removals count as evidence.</a:t>
+            </a:r>
+          </a:p>
+        </p:txBody>
+      </p:sp>
+      <p:sp>
+        <p:nvSpPr>
+          <p:cNvPr id="4" name="Slide Number Placeholder 3"/>
+          <p:cNvSpPr>
+            <a:spLocks noGrp="1"/>
+          </p:cNvSpPr>
+          <p:nvPr>
+            <p:ph type="sldNum" idx="5" sz="quarter"/>
+          </p:nvPr>
+        </p:nvSpPr>
+        <p:spPr/>
+      </p:sp>
+    </p:spTree>
+  </p:cSld>
+  <p:clrMapOvr>
+    <a:masterClrMapping/>
+  </p:clrMapOvr>
+</p:notes>
+</file>
+
+<file path=ppt/notesSlides/notesSlide32.xml><?xml version="1.0" encoding="utf-8"?>
+<p:notes xmlns:a="http://schemas.openxmlformats.org/drawingml/2006/main" xmlns:p="http://schemas.openxmlformats.org/presentationml/2006/main" xmlns:r="http://schemas.openxmlformats.org/officeDocument/2006/relationships">
+  <p:cSld>
+    <p:spTree>
+      <p:nvGrpSpPr>
+        <p:cNvPr id="1" name=""/>
+        <p:cNvGrpSpPr/>
+        <p:nvPr/>
+      </p:nvGrpSpPr>
+      <p:grpSpPr>
+        <a:xfrm>
+          <a:off x="0" y="0"/>
+          <a:ext cx="0" cy="0"/>
+          <a:chOff x="0" y="0"/>
+          <a:chExt cx="0" cy="0"/>
+        </a:xfrm>
+      </p:grpSpPr>
+      <p:sp>
+        <p:nvSpPr>
+          <p:cNvPr id="2" name="Slide Image Placeholder 1"/>
+          <p:cNvSpPr>
+            <a:spLocks noGrp="1"/>
+          </p:cNvSpPr>
+          <p:nvPr>
+            <p:ph type="sldImg" idx="2"/>
+          </p:nvPr>
+        </p:nvSpPr>
+        <p:spPr/>
+      </p:sp>
+      <p:sp>
+        <p:nvSpPr>
+          <p:cNvPr id="3" name="Notes Placeholder 2"/>
+          <p:cNvSpPr>
+            <a:spLocks noGrp="1"/>
+          </p:cNvSpPr>
+          <p:nvPr>
+            <p:ph type="body" idx="3" sz="quarter"/>
+          </p:nvPr>
+        </p:nvSpPr>
+        <p:spPr/>
+        <p:txBody>
+          <a:bodyPr/>
+          <a:lstStyle/>
+          <a:p>
+            <a:r>
+              <a:t>Step 1 is fully automatic and tells you whether steps 2 to 4 are needed at all. The airline numbers on the right are the checks this talk evaluated, packaged in the doctor. Minimum a benchmark must expose: a way to run an empty agent and a state-based grader. Twins need a settable initial state and the ability to score a hand-made trajectory. Policy flips need the policy as plain text in the agent's prompt. Every tau2 tool already carries a READ or WRITE label, so the doctor uses those instead of hand-written sets.</a:t>
+            </a:r>
+          </a:p>
+        </p:txBody>
+      </p:sp>
+      <p:sp>
+        <p:nvSpPr>
+          <p:cNvPr id="4" name="Slide Number Placeholder 3"/>
+          <p:cNvSpPr>
+            <a:spLocks noGrp="1"/>
+          </p:cNvSpPr>
+          <p:nvPr>
+            <p:ph type="sldNum" idx="5" sz="quarter"/>
+          </p:nvPr>
+        </p:nvSpPr>
+        <p:spPr/>
+      </p:sp>
+    </p:spTree>
+  </p:cSld>
+  <p:clrMapOvr>
+    <a:masterClrMapping/>
+  </p:clrMapOvr>
+</p:notes>
+</file>
+
+<file path=ppt/notesSlides/notesSlide33.xml><?xml version="1.0" encoding="utf-8"?>
+<p:notes xmlns:a="http://schemas.openxmlformats.org/drawingml/2006/main" xmlns:p="http://schemas.openxmlformats.org/presentationml/2006/main" xmlns:r="http://schemas.openxmlformats.org/officeDocument/2006/relationships">
+  <p:cSld>
+    <p:spTree>
+      <p:nvGrpSpPr>
+        <p:cNvPr id="1" name=""/>
+        <p:cNvGrpSpPr/>
+        <p:nvPr/>
+      </p:nvGrpSpPr>
+      <p:grpSpPr>
+        <a:xfrm>
+          <a:off x="0" y="0"/>
+          <a:ext cx="0" cy="0"/>
+          <a:chOff x="0" y="0"/>
+          <a:chExt cx="0" cy="0"/>
+        </a:xfrm>
+      </p:grpSpPr>
+      <p:sp>
+        <p:nvSpPr>
+          <p:cNvPr id="2" name="Slide Image Placeholder 1"/>
+          <p:cNvSpPr>
+            <a:spLocks noGrp="1"/>
+          </p:cNvSpPr>
+          <p:nvPr>
+            <p:ph type="sldImg" idx="2"/>
+          </p:nvPr>
+        </p:nvSpPr>
+        <p:spPr/>
+      </p:sp>
+      <p:sp>
+        <p:nvSpPr>
+          <p:cNvPr id="3" name="Notes Placeholder 2"/>
+          <p:cNvSpPr>
+            <a:spLocks noGrp="1"/>
+          </p:cNvSpPr>
+          <p:nvPr>
+            <p:ph type="body" idx="3" sz="quarter"/>
+          </p:nvPr>
+        </p:nvSpPr>
+        <p:spPr/>
+        <p:txBody>
+          <a:bodyPr/>
+          <a:lstStyle/>
+          <a:p>
+            <a:r>
+              <a:t>In the screenshot, the top twin (reservation made within 24 hours) passes validation. The bottom one was edited by hand to a bad patch, and the grader's validation error shows right away. Every review records who approved what, and when.</a:t>
             </a:r>
           </a:p>
         </p:txBody>
@@ -6354,7 +6496,7 @@
       <p:grpSpPr/>
       <p:pic>
         <p:nvPicPr>
-          <p:cNvPr id="2" name="sec-discussion" descr="sec-discussion.png"/>
+          <p:cNvPr id="2" name="limitations" descr="limitations.png"/>
           <p:cNvPicPr>
             <a:picLocks noChangeAspect="1"/>
           </p:cNvPicPr>
@@ -6385,6 +6527,132 @@
 </file>
 
 <file path=ppt/slides/slide26.xml><?xml version="1.0" encoding="utf-8"?>
+<p:sld xmlns:a="http://schemas.openxmlformats.org/drawingml/2006/main" xmlns:p="http://schemas.openxmlformats.org/presentationml/2006/main" xmlns:r="http://schemas.openxmlformats.org/officeDocument/2006/relationships">
+  <p:cSld>
+    <p:spTree>
+      <p:nvGrpSpPr>
+        <p:cNvPr id="1" name=""/>
+        <p:cNvGrpSpPr/>
+        <p:nvPr/>
+      </p:nvGrpSpPr>
+      <p:grpSpPr/>
+      <p:pic>
+        <p:nvPicPr>
+          <p:cNvPr id="2" name="takeaways" descr="takeaways.png"/>
+          <p:cNvPicPr>
+            <a:picLocks noChangeAspect="1"/>
+          </p:cNvPicPr>
+          <p:nvPr/>
+        </p:nvPicPr>
+        <p:blipFill>
+          <a:blip r:embed="rId2"/>
+          <a:stretch>
+            <a:fillRect/>
+          </a:stretch>
+        </p:blipFill>
+        <p:spPr>
+          <a:xfrm>
+            <a:off x="0" y="0"/>
+            <a:ext cx="12192000" cy="6858000"/>
+          </a:xfrm>
+          <a:prstGeom prst="rect">
+            <a:avLst/>
+          </a:prstGeom>
+        </p:spPr>
+      </p:pic>
+    </p:spTree>
+  </p:cSld>
+  <p:clrMapOvr>
+    <a:masterClrMapping/>
+  </p:clrMapOvr>
+</p:sld>
+</file>
+
+<file path=ppt/slides/slide27.xml><?xml version="1.0" encoding="utf-8"?>
+<p:sld xmlns:a="http://schemas.openxmlformats.org/drawingml/2006/main" xmlns:p="http://schemas.openxmlformats.org/presentationml/2006/main" xmlns:r="http://schemas.openxmlformats.org/officeDocument/2006/relationships">
+  <p:cSld>
+    <p:spTree>
+      <p:nvGrpSpPr>
+        <p:cNvPr id="1" name=""/>
+        <p:cNvGrpSpPr/>
+        <p:nvPr/>
+      </p:nvGrpSpPr>
+      <p:grpSpPr/>
+      <p:pic>
+        <p:nvPicPr>
+          <p:cNvPr id="2" name="questions" descr="questions.png"/>
+          <p:cNvPicPr>
+            <a:picLocks noChangeAspect="1"/>
+          </p:cNvPicPr>
+          <p:nvPr/>
+        </p:nvPicPr>
+        <p:blipFill>
+          <a:blip r:embed="rId2"/>
+          <a:stretch>
+            <a:fillRect/>
+          </a:stretch>
+        </p:blipFill>
+        <p:spPr>
+          <a:xfrm>
+            <a:off x="0" y="0"/>
+            <a:ext cx="12192000" cy="6858000"/>
+          </a:xfrm>
+          <a:prstGeom prst="rect">
+            <a:avLst/>
+          </a:prstGeom>
+        </p:spPr>
+      </p:pic>
+    </p:spTree>
+  </p:cSld>
+  <p:clrMapOvr>
+    <a:masterClrMapping/>
+  </p:clrMapOvr>
+</p:sld>
+</file>
+
+<file path=ppt/slides/slide28.xml><?xml version="1.0" encoding="utf-8"?>
+<p:sld xmlns:a="http://schemas.openxmlformats.org/drawingml/2006/main" xmlns:p="http://schemas.openxmlformats.org/presentationml/2006/main" xmlns:r="http://schemas.openxmlformats.org/officeDocument/2006/relationships">
+  <p:cSld>
+    <p:spTree>
+      <p:nvGrpSpPr>
+        <p:cNvPr id="1" name=""/>
+        <p:cNvGrpSpPr/>
+        <p:nvPr/>
+      </p:nvGrpSpPr>
+      <p:grpSpPr/>
+      <p:pic>
+        <p:nvPicPr>
+          <p:cNvPr id="2" name="sec-appendix" descr="sec-appendix.png"/>
+          <p:cNvPicPr>
+            <a:picLocks noChangeAspect="1"/>
+          </p:cNvPicPr>
+          <p:nvPr/>
+        </p:nvPicPr>
+        <p:blipFill>
+          <a:blip r:embed="rId2"/>
+          <a:stretch>
+            <a:fillRect/>
+          </a:stretch>
+        </p:blipFill>
+        <p:spPr>
+          <a:xfrm>
+            <a:off x="0" y="0"/>
+            <a:ext cx="12192000" cy="6858000"/>
+          </a:xfrm>
+          <a:prstGeom prst="rect">
+            <a:avLst/>
+          </a:prstGeom>
+        </p:spPr>
+      </p:pic>
+    </p:spTree>
+  </p:cSld>
+  <p:clrMapOvr>
+    <a:masterClrMapping/>
+  </p:clrMapOvr>
+</p:sld>
+</file>
+
+<file path=ppt/slides/slide29.xml><?xml version="1.0" encoding="utf-8"?>
 <p:sld xmlns:a="http://schemas.openxmlformats.org/drawingml/2006/main" xmlns:p="http://schemas.openxmlformats.org/presentationml/2006/main" xmlns:r="http://schemas.openxmlformats.org/officeDocument/2006/relationships">
   <p:cSld>
     <p:spTree>
@@ -6426,7 +6694,133 @@
 </p:sld>
 </file>
 
-<file path=ppt/slides/slide27.xml><?xml version="1.0" encoding="utf-8"?>
+<file path=ppt/slides/slide3.xml><?xml version="1.0" encoding="utf-8"?>
+<p:sld xmlns:a="http://schemas.openxmlformats.org/drawingml/2006/main" xmlns:p="http://schemas.openxmlformats.org/presentationml/2006/main" xmlns:r="http://schemas.openxmlformats.org/officeDocument/2006/relationships">
+  <p:cSld>
+    <p:spTree>
+      <p:nvGrpSpPr>
+        <p:cNvPr id="1" name=""/>
+        <p:cNvGrpSpPr/>
+        <p:nvPr/>
+      </p:nvGrpSpPr>
+      <p:grpSpPr/>
+      <p:pic>
+        <p:nvPicPr>
+          <p:cNvPr id="2" name="motivation" descr="motivation.png"/>
+          <p:cNvPicPr>
+            <a:picLocks noChangeAspect="1"/>
+          </p:cNvPicPr>
+          <p:nvPr/>
+        </p:nvPicPr>
+        <p:blipFill>
+          <a:blip r:embed="rId2"/>
+          <a:stretch>
+            <a:fillRect/>
+          </a:stretch>
+        </p:blipFill>
+        <p:spPr>
+          <a:xfrm>
+            <a:off x="0" y="0"/>
+            <a:ext cx="12192000" cy="6858000"/>
+          </a:xfrm>
+          <a:prstGeom prst="rect">
+            <a:avLst/>
+          </a:prstGeom>
+        </p:spPr>
+      </p:pic>
+    </p:spTree>
+  </p:cSld>
+  <p:clrMapOvr>
+    <a:masterClrMapping/>
+  </p:clrMapOvr>
+</p:sld>
+</file>
+
+<file path=ppt/slides/slide30.xml><?xml version="1.0" encoding="utf-8"?>
+<p:sld xmlns:a="http://schemas.openxmlformats.org/drawingml/2006/main" xmlns:p="http://schemas.openxmlformats.org/presentationml/2006/main" xmlns:r="http://schemas.openxmlformats.org/officeDocument/2006/relationships">
+  <p:cSld>
+    <p:spTree>
+      <p:nvGrpSpPr>
+        <p:cNvPr id="1" name=""/>
+        <p:cNvGrpSpPr/>
+        <p:nvPr/>
+      </p:nvGrpSpPr>
+      <p:grpSpPr/>
+      <p:pic>
+        <p:nvPicPr>
+          <p:cNvPr id="2" name="removal-causes" descr="removal-causes.png"/>
+          <p:cNvPicPr>
+            <a:picLocks noChangeAspect="1"/>
+          </p:cNvPicPr>
+          <p:nvPr/>
+        </p:nvPicPr>
+        <p:blipFill>
+          <a:blip r:embed="rId2"/>
+          <a:stretch>
+            <a:fillRect/>
+          </a:stretch>
+        </p:blipFill>
+        <p:spPr>
+          <a:xfrm>
+            <a:off x="0" y="0"/>
+            <a:ext cx="12192000" cy="6858000"/>
+          </a:xfrm>
+          <a:prstGeom prst="rect">
+            <a:avLst/>
+          </a:prstGeom>
+        </p:spPr>
+      </p:pic>
+    </p:spTree>
+  </p:cSld>
+  <p:clrMapOvr>
+    <a:masterClrMapping/>
+  </p:clrMapOvr>
+</p:sld>
+</file>
+
+<file path=ppt/slides/slide31.xml><?xml version="1.0" encoding="utf-8"?>
+<p:sld xmlns:a="http://schemas.openxmlformats.org/drawingml/2006/main" xmlns:p="http://schemas.openxmlformats.org/presentationml/2006/main" xmlns:r="http://schemas.openxmlformats.org/officeDocument/2006/relationships">
+  <p:cSld>
+    <p:spTree>
+      <p:nvGrpSpPr>
+        <p:cNvPr id="1" name=""/>
+        <p:cNvGrpSpPr/>
+        <p:nvPr/>
+      </p:nvGrpSpPr>
+      <p:grpSpPr/>
+      <p:pic>
+        <p:nvPicPr>
+          <p:cNvPr id="2" name="limits" descr="limits.png"/>
+          <p:cNvPicPr>
+            <a:picLocks noChangeAspect="1"/>
+          </p:cNvPicPr>
+          <p:nvPr/>
+        </p:nvPicPr>
+        <p:blipFill>
+          <a:blip r:embed="rId2"/>
+          <a:stretch>
+            <a:fillRect/>
+          </a:stretch>
+        </p:blipFill>
+        <p:spPr>
+          <a:xfrm>
+            <a:off x="0" y="0"/>
+            <a:ext cx="12192000" cy="6858000"/>
+          </a:xfrm>
+          <a:prstGeom prst="rect">
+            <a:avLst/>
+          </a:prstGeom>
+        </p:spPr>
+      </p:pic>
+    </p:spTree>
+  </p:cSld>
+  <p:clrMapOvr>
+    <a:masterClrMapping/>
+  </p:clrMapOvr>
+</p:sld>
+</file>
+
+<file path=ppt/slides/slide32.xml><?xml version="1.0" encoding="utf-8"?>
 <p:sld xmlns:a="http://schemas.openxmlformats.org/drawingml/2006/main" xmlns:p="http://schemas.openxmlformats.org/presentationml/2006/main" xmlns:r="http://schemas.openxmlformats.org/officeDocument/2006/relationships">
   <p:cSld>
     <p:spTree>
@@ -6468,7 +6862,7 @@
 </p:sld>
 </file>
 
-<file path=ppt/slides/slide28.xml><?xml version="1.0" encoding="utf-8"?>
+<file path=ppt/slides/slide33.xml><?xml version="1.0" encoding="utf-8"?>
 <p:sld xmlns:a="http://schemas.openxmlformats.org/drawingml/2006/main" xmlns:p="http://schemas.openxmlformats.org/presentationml/2006/main" xmlns:r="http://schemas.openxmlformats.org/officeDocument/2006/relationships">
   <p:cSld>
     <p:spTree>
@@ -6481,174 +6875,6 @@
       <p:pic>
         <p:nvPicPr>
           <p:cNvPr id="2" name="doctor-ui" descr="doctor-ui.png"/>
-          <p:cNvPicPr>
-            <a:picLocks noChangeAspect="1"/>
-          </p:cNvPicPr>
-          <p:nvPr/>
-        </p:nvPicPr>
-        <p:blipFill>
-          <a:blip r:embed="rId2"/>
-          <a:stretch>
-            <a:fillRect/>
-          </a:stretch>
-        </p:blipFill>
-        <p:spPr>
-          <a:xfrm>
-            <a:off x="0" y="0"/>
-            <a:ext cx="12192000" cy="6858000"/>
-          </a:xfrm>
-          <a:prstGeom prst="rect">
-            <a:avLst/>
-          </a:prstGeom>
-        </p:spPr>
-      </p:pic>
-    </p:spTree>
-  </p:cSld>
-  <p:clrMapOvr>
-    <a:masterClrMapping/>
-  </p:clrMapOvr>
-</p:sld>
-</file>
-
-<file path=ppt/slides/slide29.xml><?xml version="1.0" encoding="utf-8"?>
-<p:sld xmlns:a="http://schemas.openxmlformats.org/drawingml/2006/main" xmlns:p="http://schemas.openxmlformats.org/presentationml/2006/main" xmlns:r="http://schemas.openxmlformats.org/officeDocument/2006/relationships">
-  <p:cSld>
-    <p:spTree>
-      <p:nvGrpSpPr>
-        <p:cNvPr id="1" name=""/>
-        <p:cNvGrpSpPr/>
-        <p:nvPr/>
-      </p:nvGrpSpPr>
-      <p:grpSpPr/>
-      <p:pic>
-        <p:nvPicPr>
-          <p:cNvPr id="2" name="removal-causes" descr="removal-causes.png"/>
-          <p:cNvPicPr>
-            <a:picLocks noChangeAspect="1"/>
-          </p:cNvPicPr>
-          <p:nvPr/>
-        </p:nvPicPr>
-        <p:blipFill>
-          <a:blip r:embed="rId2"/>
-          <a:stretch>
-            <a:fillRect/>
-          </a:stretch>
-        </p:blipFill>
-        <p:spPr>
-          <a:xfrm>
-            <a:off x="0" y="0"/>
-            <a:ext cx="12192000" cy="6858000"/>
-          </a:xfrm>
-          <a:prstGeom prst="rect">
-            <a:avLst/>
-          </a:prstGeom>
-        </p:spPr>
-      </p:pic>
-    </p:spTree>
-  </p:cSld>
-  <p:clrMapOvr>
-    <a:masterClrMapping/>
-  </p:clrMapOvr>
-</p:sld>
-</file>
-
-<file path=ppt/slides/slide3.xml><?xml version="1.0" encoding="utf-8"?>
-<p:sld xmlns:a="http://schemas.openxmlformats.org/drawingml/2006/main" xmlns:p="http://schemas.openxmlformats.org/presentationml/2006/main" xmlns:r="http://schemas.openxmlformats.org/officeDocument/2006/relationships">
-  <p:cSld>
-    <p:spTree>
-      <p:nvGrpSpPr>
-        <p:cNvPr id="1" name=""/>
-        <p:cNvGrpSpPr/>
-        <p:nvPr/>
-      </p:nvGrpSpPr>
-      <p:grpSpPr/>
-      <p:pic>
-        <p:nvPicPr>
-          <p:cNvPr id="2" name="motivation" descr="motivation.png"/>
-          <p:cNvPicPr>
-            <a:picLocks noChangeAspect="1"/>
-          </p:cNvPicPr>
-          <p:nvPr/>
-        </p:nvPicPr>
-        <p:blipFill>
-          <a:blip r:embed="rId2"/>
-          <a:stretch>
-            <a:fillRect/>
-          </a:stretch>
-        </p:blipFill>
-        <p:spPr>
-          <a:xfrm>
-            <a:off x="0" y="0"/>
-            <a:ext cx="12192000" cy="6858000"/>
-          </a:xfrm>
-          <a:prstGeom prst="rect">
-            <a:avLst/>
-          </a:prstGeom>
-        </p:spPr>
-      </p:pic>
-    </p:spTree>
-  </p:cSld>
-  <p:clrMapOvr>
-    <a:masterClrMapping/>
-  </p:clrMapOvr>
-</p:sld>
-</file>
-
-<file path=ppt/slides/slide30.xml><?xml version="1.0" encoding="utf-8"?>
-<p:sld xmlns:a="http://schemas.openxmlformats.org/drawingml/2006/main" xmlns:p="http://schemas.openxmlformats.org/presentationml/2006/main" xmlns:r="http://schemas.openxmlformats.org/officeDocument/2006/relationships">
-  <p:cSld>
-    <p:spTree>
-      <p:nvGrpSpPr>
-        <p:cNvPr id="1" name=""/>
-        <p:cNvGrpSpPr/>
-        <p:nvPr/>
-      </p:nvGrpSpPr>
-      <p:grpSpPr/>
-      <p:pic>
-        <p:nvPicPr>
-          <p:cNvPr id="2" name="limits" descr="limits.png"/>
-          <p:cNvPicPr>
-            <a:picLocks noChangeAspect="1"/>
-          </p:cNvPicPr>
-          <p:nvPr/>
-        </p:nvPicPr>
-        <p:blipFill>
-          <a:blip r:embed="rId2"/>
-          <a:stretch>
-            <a:fillRect/>
-          </a:stretch>
-        </p:blipFill>
-        <p:spPr>
-          <a:xfrm>
-            <a:off x="0" y="0"/>
-            <a:ext cx="12192000" cy="6858000"/>
-          </a:xfrm>
-          <a:prstGeom prst="rect">
-            <a:avLst/>
-          </a:prstGeom>
-        </p:spPr>
-      </p:pic>
-    </p:spTree>
-  </p:cSld>
-  <p:clrMapOvr>
-    <a:masterClrMapping/>
-  </p:clrMapOvr>
-</p:sld>
-</file>
-
-<file path=ppt/slides/slide31.xml><?xml version="1.0" encoding="utf-8"?>
-<p:sld xmlns:a="http://schemas.openxmlformats.org/drawingml/2006/main" xmlns:p="http://schemas.openxmlformats.org/presentationml/2006/main" xmlns:r="http://schemas.openxmlformats.org/officeDocument/2006/relationships">
-  <p:cSld>
-    <p:spTree>
-      <p:nvGrpSpPr>
-        <p:cNvPr id="1" name=""/>
-        <p:cNvGrpSpPr/>
-        <p:nvPr/>
-      </p:nvGrpSpPr>
-      <p:grpSpPr/>
-      <p:pic>
-        <p:nvPicPr>
-          <p:cNvPr id="2" name="takeaways" descr="takeaways.png"/>
           <p:cNvPicPr>
             <a:picLocks noChangeAspect="1"/>
           </p:cNvPicPr>

</xml_diff>

<commit_message>
Presentation: export vatsal's latest deck edits
Co-Authored-By: Claude Opus 5.5 (1M context) <noreply@anthropic.com>
Claude-Session: https://claude.ai/code/session_01MtfJPedLYuXacbp8WXfd3s
</commit_message>
<xml_diff>
--- a/docs/drafts/2026-10-10-presentation-no-op-validity.pptx
+++ b/docs/drafts/2026-10-10-presentation-no-op-validity.pptx
@@ -38,6 +38,7 @@
     <p:sldId id="286" r:id="rId38"/>
     <p:sldId id="287" r:id="rId39"/>
     <p:sldId id="288" r:id="rId40"/>
+    <p:sldId id="289" r:id="rId41"/>
   </p:sldIdLst>
   <p:sldSz cx="12192000" cy="6858000" type="screen4x3"/>
   <p:notesSz cx="6858000" cy="9144000"/>
@@ -1794,7 +1795,7 @@
           <a:lstStyle/>
           <a:p>
             <a:r>
-              <a:t>Null agent 23 of 50 originally, 7 under the read gate, 3 under reads plus all twins. luna goes 39.0 to 35.7. Thank you; questions.</a:t>
+              <a:t>End of the talk. The appendix follows.</a:t>
             </a:r>
           </a:p>
         </p:txBody>
@@ -1864,7 +1865,7 @@
           <a:lstStyle/>
           <a:p>
             <a:r>
-              <a:t>End of the talk. The appendix follows.</a:t>
+              <a:t>Backup slides for questions.</a:t>
             </a:r>
           </a:p>
         </p:txBody>
@@ -1934,7 +1935,7 @@
           <a:lstStyle/>
           <a:p>
             <a:r>
-              <a:t>Backup slides for questions.</a:t>
+              <a:t>An attempted write is a real call that failed or changed nothing, or a write typed as text and lost. Most are maverick's. The projection is of the headline score (reads plus all twins) and is not yet computed by the scoreboard. The null agent stays at 3. This revives something close to the formalization's "no forbidden writes" check, set aside on 2026-10-03, so it needs a decisions-log entry.</a:t>
             </a:r>
           </a:p>
         </p:txBody>
@@ -2004,7 +2005,7 @@
           <a:lstStyle/>
           <a:p>
             <a:r>
-              <a:t>An attempted write is a real call that failed or changed nothing, or a write typed as text and lost. Most are maverick's. The projection is of the headline score (reads plus all twins) and is not yet computed by the scoreboard. The null agent stays at 3. This revives something close to the formalization's "no forbidden writes" check, set aside on 2026-10-03, so it needs a decisions-log entry.</a:t>
+              <a:t>The read gate is precise: every removal was an unreasoned pass. The twins also remove passes for reasons other than the agent's decision. Of the 9 DB-flip cases, 5 are maverick's (3 lost text calls on task 49, 2 rule errors) and 3 are haiku's business-cabin refusals. Most policy-flip cases come from the user scripts for tasks 2, 5 and 27. Fixes: detect text-form tool calls, fix the scripts, and add placebo twins to measure noise.</a:t>
             </a:r>
           </a:p>
         </p:txBody>
@@ -2144,7 +2145,7 @@
           <a:lstStyle/>
           <a:p>
             <a:r>
-              <a:t>The read gate is precise: every removal was an unreasoned pass. The twins also remove passes for reasons other than the agent's decision. Of the 9 DB-flip cases, 5 are maverick's (3 lost text calls on task 49, 2 rule errors) and 3 are haiku's business-cabin refusals. Most policy-flip cases come from the user scripts for tasks 2, 5 and 27. Fixes: detect text-form tool calls, fix the scripts, and add placebo twins to measure noise.</a:t>
+              <a:t>Say these plainly. The reads gate result is solid. The DB twin result is solid on competent models, but some removals come from lost tool calls. The policy twin needs fixed scripts before any of its removals count as evidence.</a:t>
             </a:r>
           </a:p>
         </p:txBody>
@@ -2214,7 +2215,7 @@
           <a:lstStyle/>
           <a:p>
             <a:r>
-              <a:t>Say these plainly. The reads gate result is solid. The DB twin result is solid on competent models, but some removals come from lost tool calls. The policy twin needs fixed scripts before any of its removals count as evidence.</a:t>
+              <a:t>Step 1 is fully automatic and tells you whether steps 2 to 4 are needed at all. The airline numbers on the right are the checks this talk evaluated, packaged in the doctor. Minimum a benchmark must expose: a way to run an empty agent and a state-based grader. Twins need a settable initial state and the ability to score a hand-made trajectory. Policy flips need the policy as plain text in the agent's prompt. Every tau2 tool already carries a READ or WRITE label, so the doctor uses those instead of hand-written sets.</a:t>
             </a:r>
           </a:p>
         </p:txBody>
@@ -2284,7 +2285,7 @@
           <a:lstStyle/>
           <a:p>
             <a:r>
-              <a:t>Step 1 is fully automatic and tells you whether steps 2 to 4 are needed at all. The airline numbers on the right are the checks this talk evaluated, packaged in the doctor. Minimum a benchmark must expose: a way to run an empty agent and a state-based grader. Twins need a settable initial state and the ability to score a hand-made trajectory. Policy flips need the policy as plain text in the agent's prompt. Every tau2 tool already carries a READ or WRITE label, so the doctor uses those instead of hand-written sets.</a:t>
+              <a:t>In the screenshot, the top twin (reservation made within 24 hours) passes validation. The bottom one was edited by hand to a bad patch, and the grader's validation error shows right away. Every review records who approved what, and when.</a:t>
             </a:r>
           </a:p>
         </p:txBody>
@@ -2354,7 +2355,77 @@
           <a:lstStyle/>
           <a:p>
             <a:r>
-              <a:t>In the screenshot, the top twin (reservation made within 24 hours) passes validation. The bottom one was edited by hand to a bad patch, and the grader's validation error shows right away. Every review records who approved what, and when.</a:t>
+              <a:t>Rubric: two questions per removal. Q1, was the original no-action pass reasoned? Q2, why did the gate fail: the intended catch, an unrelated agent error, the user script or simulator, or a lost tool call. "Right, wrong cause" means the original was unreasoned but the gate fired for another reason. The labels come from LLM reviewers, with no blind second labeller yet.</a:t>
+            </a:r>
+          </a:p>
+        </p:txBody>
+      </p:sp>
+      <p:sp>
+        <p:nvSpPr>
+          <p:cNvPr id="4" name="Slide Number Placeholder 3"/>
+          <p:cNvSpPr>
+            <a:spLocks noGrp="1"/>
+          </p:cNvSpPr>
+          <p:nvPr>
+            <p:ph type="sldNum" idx="5" sz="quarter"/>
+          </p:nvPr>
+        </p:nvSpPr>
+        <p:spPr/>
+      </p:sp>
+    </p:spTree>
+  </p:cSld>
+  <p:clrMapOvr>
+    <a:masterClrMapping/>
+  </p:clrMapOvr>
+</p:notes>
+</file>
+
+<file path=ppt/notesSlides/notesSlide34.xml><?xml version="1.0" encoding="utf-8"?>
+<p:notes xmlns:a="http://schemas.openxmlformats.org/drawingml/2006/main" xmlns:p="http://schemas.openxmlformats.org/presentationml/2006/main" xmlns:r="http://schemas.openxmlformats.org/officeDocument/2006/relationships">
+  <p:cSld>
+    <p:spTree>
+      <p:nvGrpSpPr>
+        <p:cNvPr id="1" name=""/>
+        <p:cNvGrpSpPr/>
+        <p:nvPr/>
+      </p:nvGrpSpPr>
+      <p:grpSpPr>
+        <a:xfrm>
+          <a:off x="0" y="0"/>
+          <a:ext cx="0" cy="0"/>
+          <a:chOff x="0" y="0"/>
+          <a:chExt cx="0" cy="0"/>
+        </a:xfrm>
+      </p:grpSpPr>
+      <p:sp>
+        <p:nvSpPr>
+          <p:cNvPr id="2" name="Slide Image Placeholder 1"/>
+          <p:cNvSpPr>
+            <a:spLocks noGrp="1"/>
+          </p:cNvSpPr>
+          <p:nvPr>
+            <p:ph type="sldImg" idx="2"/>
+          </p:nvPr>
+        </p:nvSpPr>
+        <p:spPr/>
+      </p:sp>
+      <p:sp>
+        <p:nvSpPr>
+          <p:cNvPr id="3" name="Notes Placeholder 2"/>
+          <p:cNvSpPr>
+            <a:spLocks noGrp="1"/>
+          </p:cNvSpPr>
+          <p:nvPr>
+            <p:ph type="body" idx="3" sz="quarter"/>
+          </p:nvPr>
+        </p:nvSpPr>
+        <p:spPr/>
+        <p:txBody>
+          <a:bodyPr/>
+          <a:lstStyle/>
+          <a:p>
+            <a:r>
+              <a:t>Section start.</a:t>
             </a:r>
           </a:p>
         </p:txBody>
@@ -6538,48 +6609,6 @@
       <p:grpSpPr/>
       <p:pic>
         <p:nvPicPr>
-          <p:cNvPr id="2" name="takeaways" descr="takeaways.png"/>
-          <p:cNvPicPr>
-            <a:picLocks noChangeAspect="1"/>
-          </p:cNvPicPr>
-          <p:nvPr/>
-        </p:nvPicPr>
-        <p:blipFill>
-          <a:blip r:embed="rId2"/>
-          <a:stretch>
-            <a:fillRect/>
-          </a:stretch>
-        </p:blipFill>
-        <p:spPr>
-          <a:xfrm>
-            <a:off x="0" y="0"/>
-            <a:ext cx="12192000" cy="6858000"/>
-          </a:xfrm>
-          <a:prstGeom prst="rect">
-            <a:avLst/>
-          </a:prstGeom>
-        </p:spPr>
-      </p:pic>
-    </p:spTree>
-  </p:cSld>
-  <p:clrMapOvr>
-    <a:masterClrMapping/>
-  </p:clrMapOvr>
-</p:sld>
-</file>
-
-<file path=ppt/slides/slide27.xml><?xml version="1.0" encoding="utf-8"?>
-<p:sld xmlns:a="http://schemas.openxmlformats.org/drawingml/2006/main" xmlns:p="http://schemas.openxmlformats.org/presentationml/2006/main" xmlns:r="http://schemas.openxmlformats.org/officeDocument/2006/relationships">
-  <p:cSld>
-    <p:spTree>
-      <p:nvGrpSpPr>
-        <p:cNvPr id="1" name=""/>
-        <p:cNvGrpSpPr/>
-        <p:nvPr/>
-      </p:nvGrpSpPr>
-      <p:grpSpPr/>
-      <p:pic>
-        <p:nvPicPr>
           <p:cNvPr id="2" name="questions" descr="questions.png"/>
           <p:cNvPicPr>
             <a:picLocks noChangeAspect="1"/>
@@ -6610,7 +6639,7 @@
 </p:sld>
 </file>
 
-<file path=ppt/slides/slide28.xml><?xml version="1.0" encoding="utf-8"?>
+<file path=ppt/slides/slide27.xml><?xml version="1.0" encoding="utf-8"?>
 <p:sld xmlns:a="http://schemas.openxmlformats.org/drawingml/2006/main" xmlns:p="http://schemas.openxmlformats.org/presentationml/2006/main" xmlns:r="http://schemas.openxmlformats.org/officeDocument/2006/relationships">
   <p:cSld>
     <p:spTree>
@@ -6652,7 +6681,7 @@
 </p:sld>
 </file>
 
-<file path=ppt/slides/slide29.xml><?xml version="1.0" encoding="utf-8"?>
+<file path=ppt/slides/slide28.xml><?xml version="1.0" encoding="utf-8"?>
 <p:sld xmlns:a="http://schemas.openxmlformats.org/drawingml/2006/main" xmlns:p="http://schemas.openxmlformats.org/presentationml/2006/main" xmlns:r="http://schemas.openxmlformats.org/officeDocument/2006/relationships">
   <p:cSld>
     <p:spTree>
@@ -6694,6 +6723,48 @@
 </p:sld>
 </file>
 
+<file path=ppt/slides/slide29.xml><?xml version="1.0" encoding="utf-8"?>
+<p:sld xmlns:a="http://schemas.openxmlformats.org/drawingml/2006/main" xmlns:p="http://schemas.openxmlformats.org/presentationml/2006/main" xmlns:r="http://schemas.openxmlformats.org/officeDocument/2006/relationships">
+  <p:cSld>
+    <p:spTree>
+      <p:nvGrpSpPr>
+        <p:cNvPr id="1" name=""/>
+        <p:cNvGrpSpPr/>
+        <p:nvPr/>
+      </p:nvGrpSpPr>
+      <p:grpSpPr/>
+      <p:pic>
+        <p:nvPicPr>
+          <p:cNvPr id="2" name="removal-causes" descr="removal-causes.png"/>
+          <p:cNvPicPr>
+            <a:picLocks noChangeAspect="1"/>
+          </p:cNvPicPr>
+          <p:nvPr/>
+        </p:nvPicPr>
+        <p:blipFill>
+          <a:blip r:embed="rId2"/>
+          <a:stretch>
+            <a:fillRect/>
+          </a:stretch>
+        </p:blipFill>
+        <p:spPr>
+          <a:xfrm>
+            <a:off x="0" y="0"/>
+            <a:ext cx="12192000" cy="6858000"/>
+          </a:xfrm>
+          <a:prstGeom prst="rect">
+            <a:avLst/>
+          </a:prstGeom>
+        </p:spPr>
+      </p:pic>
+    </p:spTree>
+  </p:cSld>
+  <p:clrMapOvr>
+    <a:masterClrMapping/>
+  </p:clrMapOvr>
+</p:sld>
+</file>
+
 <file path=ppt/slides/slide3.xml><?xml version="1.0" encoding="utf-8"?>
 <p:sld xmlns:a="http://schemas.openxmlformats.org/drawingml/2006/main" xmlns:p="http://schemas.openxmlformats.org/presentationml/2006/main" xmlns:r="http://schemas.openxmlformats.org/officeDocument/2006/relationships">
   <p:cSld>
@@ -6748,48 +6819,6 @@
       <p:grpSpPr/>
       <p:pic>
         <p:nvPicPr>
-          <p:cNvPr id="2" name="removal-causes" descr="removal-causes.png"/>
-          <p:cNvPicPr>
-            <a:picLocks noChangeAspect="1"/>
-          </p:cNvPicPr>
-          <p:nvPr/>
-        </p:nvPicPr>
-        <p:blipFill>
-          <a:blip r:embed="rId2"/>
-          <a:stretch>
-            <a:fillRect/>
-          </a:stretch>
-        </p:blipFill>
-        <p:spPr>
-          <a:xfrm>
-            <a:off x="0" y="0"/>
-            <a:ext cx="12192000" cy="6858000"/>
-          </a:xfrm>
-          <a:prstGeom prst="rect">
-            <a:avLst/>
-          </a:prstGeom>
-        </p:spPr>
-      </p:pic>
-    </p:spTree>
-  </p:cSld>
-  <p:clrMapOvr>
-    <a:masterClrMapping/>
-  </p:clrMapOvr>
-</p:sld>
-</file>
-
-<file path=ppt/slides/slide31.xml><?xml version="1.0" encoding="utf-8"?>
-<p:sld xmlns:a="http://schemas.openxmlformats.org/drawingml/2006/main" xmlns:p="http://schemas.openxmlformats.org/presentationml/2006/main" xmlns:r="http://schemas.openxmlformats.org/officeDocument/2006/relationships">
-  <p:cSld>
-    <p:spTree>
-      <p:nvGrpSpPr>
-        <p:cNvPr id="1" name=""/>
-        <p:cNvGrpSpPr/>
-        <p:nvPr/>
-      </p:nvGrpSpPr>
-      <p:grpSpPr/>
-      <p:pic>
-        <p:nvPicPr>
           <p:cNvPr id="2" name="limits" descr="limits.png"/>
           <p:cNvPicPr>
             <a:picLocks noChangeAspect="1"/>
@@ -6820,7 +6849,7 @@
 </p:sld>
 </file>
 
-<file path=ppt/slides/slide32.xml><?xml version="1.0" encoding="utf-8"?>
+<file path=ppt/slides/slide31.xml><?xml version="1.0" encoding="utf-8"?>
 <p:sld xmlns:a="http://schemas.openxmlformats.org/drawingml/2006/main" xmlns:p="http://schemas.openxmlformats.org/presentationml/2006/main" xmlns:r="http://schemas.openxmlformats.org/officeDocument/2006/relationships">
   <p:cSld>
     <p:spTree>
@@ -6862,7 +6891,7 @@
 </p:sld>
 </file>
 
-<file path=ppt/slides/slide33.xml><?xml version="1.0" encoding="utf-8"?>
+<file path=ppt/slides/slide32.xml><?xml version="1.0" encoding="utf-8"?>
 <p:sld xmlns:a="http://schemas.openxmlformats.org/drawingml/2006/main" xmlns:p="http://schemas.openxmlformats.org/presentationml/2006/main" xmlns:r="http://schemas.openxmlformats.org/officeDocument/2006/relationships">
   <p:cSld>
     <p:spTree>
@@ -6875,6 +6904,90 @@
       <p:pic>
         <p:nvPicPr>
           <p:cNvPr id="2" name="doctor-ui" descr="doctor-ui.png"/>
+          <p:cNvPicPr>
+            <a:picLocks noChangeAspect="1"/>
+          </p:cNvPicPr>
+          <p:nvPr/>
+        </p:nvPicPr>
+        <p:blipFill>
+          <a:blip r:embed="rId2"/>
+          <a:stretch>
+            <a:fillRect/>
+          </a:stretch>
+        </p:blipFill>
+        <p:spPr>
+          <a:xfrm>
+            <a:off x="0" y="0"/>
+            <a:ext cx="12192000" cy="6858000"/>
+          </a:xfrm>
+          <a:prstGeom prst="rect">
+            <a:avLst/>
+          </a:prstGeom>
+        </p:spPr>
+      </p:pic>
+    </p:spTree>
+  </p:cSld>
+  <p:clrMapOvr>
+    <a:masterClrMapping/>
+  </p:clrMapOvr>
+</p:sld>
+</file>
+
+<file path=ppt/slides/slide33.xml><?xml version="1.0" encoding="utf-8"?>
+<p:sld xmlns:a="http://schemas.openxmlformats.org/drawingml/2006/main" xmlns:p="http://schemas.openxmlformats.org/presentationml/2006/main" xmlns:r="http://schemas.openxmlformats.org/officeDocument/2006/relationships">
+  <p:cSld>
+    <p:spTree>
+      <p:nvGrpSpPr>
+        <p:cNvPr id="1" name=""/>
+        <p:cNvGrpSpPr/>
+        <p:nvPr/>
+      </p:nvGrpSpPr>
+      <p:grpSpPr/>
+      <p:pic>
+        <p:nvPicPr>
+          <p:cNvPr id="2" name="qual-scorecard" descr="qual-scorecard.png"/>
+          <p:cNvPicPr>
+            <a:picLocks noChangeAspect="1"/>
+          </p:cNvPicPr>
+          <p:nvPr/>
+        </p:nvPicPr>
+        <p:blipFill>
+          <a:blip r:embed="rId2"/>
+          <a:stretch>
+            <a:fillRect/>
+          </a:stretch>
+        </p:blipFill>
+        <p:spPr>
+          <a:xfrm>
+            <a:off x="0" y="0"/>
+            <a:ext cx="12192000" cy="6858000"/>
+          </a:xfrm>
+          <a:prstGeom prst="rect">
+            <a:avLst/>
+          </a:prstGeom>
+        </p:spPr>
+      </p:pic>
+    </p:spTree>
+  </p:cSld>
+  <p:clrMapOvr>
+    <a:masterClrMapping/>
+  </p:clrMapOvr>
+</p:sld>
+</file>
+
+<file path=ppt/slides/slide34.xml><?xml version="1.0" encoding="utf-8"?>
+<p:sld xmlns:a="http://schemas.openxmlformats.org/drawingml/2006/main" xmlns:p="http://schemas.openxmlformats.org/presentationml/2006/main" xmlns:r="http://schemas.openxmlformats.org/officeDocument/2006/relationships">
+  <p:cSld>
+    <p:spTree>
+      <p:nvGrpSpPr>
+        <p:cNvPr id="1" name=""/>
+        <p:cNvGrpSpPr/>
+        <p:nvPr/>
+      </p:nvGrpSpPr>
+      <p:grpSpPr/>
+      <p:pic>
+        <p:nvPicPr>
+          <p:cNvPr id="2" name="sec-discussion" descr="sec-discussion.png"/>
           <p:cNvPicPr>
             <a:picLocks noChangeAspect="1"/>
           </p:cNvPicPr>

</xml_diff>